<commit_message>
feat: complete legal strategy report for Liao Kuang-Hui and Chan Ming-Hui case
</commit_message>
<xml_diff>
--- a/3.住/legal_strategy_presentation.pptx
+++ b/3.住/legal_strategy_presentation.pptx
@@ -10,8 +10,6 @@
     <p:sldId id="258" r:id="rId9"/>
     <p:sldId id="259" r:id="rId10"/>
     <p:sldId id="260" r:id="rId11"/>
-    <p:sldId id="261" r:id="rId12"/>
-    <p:sldId id="262" r:id="rId13"/>
   </p:sldIdLst>
   <p:sldSz cx="12191695" cy="6858000" type="screen4x3"/>
   <p:notesSz cx="6858000" cy="9144000"/>
@@ -3169,8 +3167,8 @@
         </p:nvSpPr>
         <p:spPr>
           <a:xfrm>
-            <a:off x="731520" y="1280160"/>
-            <a:ext cx="5303520" cy="4572000"/>
+            <a:off x="731520" y="1188720"/>
+            <a:ext cx="5303520" cy="4754880"/>
           </a:xfrm>
           <a:prstGeom prst="rect">
             <a:avLst/>
@@ -3184,38 +3182,38 @@
           <a:lstStyle/>
           <a:p>
             <a:r>
-              <a:rPr sz="3200" b="1">
+              <a:rPr sz="3000" b="1">
                 <a:solidFill>
                   <a:srgbClr val="DE5814"/>
                 </a:solidFill>
                 <a:latin typeface="PingFang TC"/>
               </a:rPr>
               <a:t>八旬失智配偶法律防禦
-與權益最大化戰略報告
+與權益最大化戰略報告書
 </a:t>
             </a:r>
           </a:p>
           <a:p>
             <a:pPr>
               <a:spcBef>
-                <a:spcPts val="1000"/>
+                <a:spcPts val="800"/>
               </a:spcBef>
             </a:pPr>
             <a:r>
-              <a:rPr sz="1400" b="1">
+              <a:rPr sz="1350" b="1">
                 <a:solidFill>
                   <a:srgbClr val="A83212"/>
                 </a:solidFill>
                 <a:latin typeface="PingFang TC"/>
               </a:rPr>
-              <a:t>阻斷惡意脫產・夫妻剩餘財產清算・監護宣告・追討第三者・照護權益全攻略
+              <a:t>阻斷廖光輝惡意脫產・向第三者湛明輝追討資產・監護宣告・夫妻剩餘財產清算全攻略
 </a:t>
             </a:r>
           </a:p>
           <a:p>
             <a:pPr>
               <a:spcBef>
-                <a:spcPts val="2400"/>
+                <a:spcPts val="2200"/>
               </a:spcBef>
             </a:pPr>
             <a:r>
@@ -3242,7 +3240,7 @@
                 </a:solidFill>
                 <a:latin typeface="PingFang TC"/>
               </a:rPr>
-              <a:t>專案性質：台灣家事法實務戰略與醫療證明指引 ｜ 2026年9月</a:t>
+              <a:t>當事人：雙方均為民國38年次（結縭近五十年） ｜ 日期：2026年9月</a:t>
             </a:r>
           </a:p>
         </p:txBody>
@@ -3327,7 +3325,7 @@
           <a:noFill/>
         </p:spPr>
         <p:txBody>
-          <a:bodyPr wrap="square" lIns="0" tIns="0" rIns="0" bIns="0">
+          <a:bodyPr wrap="square">
             <a:spAutoFit/>
           </a:bodyPr>
           <a:lstStyle/>
@@ -3339,7 +3337,7 @@
                 </a:solidFill>
                 <a:latin typeface="PingFang TC"/>
               </a:rPr>
-              <a:t>【醫療證據】 </a:t>
+              <a:t>【戰略分析】 </a:t>
             </a:r>
             <a:r>
               <a:rPr sz="2400" b="1">
@@ -3348,7 +3346,7 @@
                 </a:solidFill>
                 <a:latin typeface="PingFang TC"/>
               </a:rPr>
-              <a:t>診斷書開立指引：律師指示與專業神經醫學用語</a:t>
+              <a:t>說明篇：三十八年次長輩半世紀婚姻與法律優勢</a:t>
             </a:r>
           </a:p>
         </p:txBody>
@@ -3404,9 +3402,9 @@
           <a:solidFill>
             <a:srgbClr val="FFFBEB"/>
           </a:solidFill>
-          <a:ln w="19050">
+          <a:ln>
             <a:solidFill>
-              <a:srgbClr val="D97706"/>
+              <a:srgbClr val="A83212"/>
             </a:solidFill>
           </a:ln>
         </p:spPr>
@@ -3425,168 +3423,89 @@
           </a:fontRef>
         </p:style>
         <p:txBody>
-          <a:bodyPr rtlCol="0" anchor="ctr" wrap="square" lIns="274320" rIns="274320" tIns="274320"/>
+          <a:bodyPr rtlCol="0" anchor="ctr" wrap="square" lIns="228600" rIns="228600" tIns="228600"/>
           <a:lstStyle/>
           <a:p>
             <a:pPr algn="ctr"/>
             <a:r>
-              <a:rPr sz="1600" b="1">
+              <a:rPr b="1" sz="1600">
                 <a:solidFill>
                   <a:srgbClr val="A83212"/>
                 </a:solidFill>
-                <a:latin typeface="PingFang TC"/>
               </a:rPr>
-              <a:t>一、醫院端神經內科「專業醫學用語」</a:t>
+              <a:t>一、法官心證：絕對不准廖光輝逼離</a:t>
             </a:r>
           </a:p>
           <a:p>
             <a:pPr>
               <a:spcBef>
-                <a:spcPts val="800"/>
+                <a:spcPts val="1000"/>
               </a:spcBef>
             </a:pPr>
             <a:r>
-              <a:rPr sz="1200" b="1">
+              <a:rPr b="1" sz="1200">
                 <a:solidFill>
                   <a:srgbClr val="D97706"/>
                 </a:solidFill>
-                <a:latin typeface="PingFang TC"/>
               </a:rPr>
-              <a:t>• 非口語「記性差」：</a:t>
-            </a:r>
-            <a:r>
-              <a:rPr sz="1100">
+              <a:t>★ 金婚五十年：
+</a:t>
+            </a:r>
+            <a:r>
+              <a:rPr sz="1050">
                 <a:solidFill>
                   <a:srgbClr val="2D3748"/>
                 </a:solidFill>
-                <a:latin typeface="PingFang TC"/>
               </a:rPr>
-              <a:t>需具體載明「阿茲海默型失智症」或「進行性腦神經退化症」。</a:t>
+              <a:t>結縭近半世紀，母親陪同白手起家操勞一生，病中遭拋棄情節重大。</a:t>
             </a:r>
           </a:p>
           <a:p>
             <a:pPr>
               <a:spcBef>
-                <a:spcPts val="800"/>
+                <a:spcPts val="1000"/>
               </a:spcBef>
             </a:pPr>
             <a:r>
-              <a:rPr sz="1200" b="1">
+              <a:rPr b="1" sz="1200">
                 <a:solidFill>
                   <a:srgbClr val="D97706"/>
                 </a:solidFill>
-                <a:latin typeface="PingFang TC"/>
               </a:rPr>
-              <a:t>• 非單純「退化」：</a:t>
-            </a:r>
-            <a:r>
-              <a:rPr sz="1100">
+              <a:t>★ 民法1052但書鐵壁：
+</a:t>
+            </a:r>
+            <a:r>
+              <a:rPr sz="1050">
                 <a:solidFill>
                   <a:srgbClr val="2D3748"/>
                 </a:solidFill>
-                <a:latin typeface="PingFang TC"/>
               </a:rPr>
-              <a:t>需載明「嚴重認知功能障礙（Severe Cognitive Impairment）」。</a:t>
+              <a:t>廖光輝外遇湛明輝為破壞婚姻唯一過失方，法律明定無權強逼病妻判決離婚。</a:t>
             </a:r>
           </a:p>
           <a:p>
             <a:pPr>
               <a:spcBef>
-                <a:spcPts val="800"/>
+                <a:spcPts val="1000"/>
               </a:spcBef>
             </a:pPr>
             <a:r>
-              <a:rPr sz="1200" b="1">
+              <a:rPr b="1" sz="1200">
                 <a:solidFill>
                   <a:srgbClr val="D97706"/>
                 </a:solidFill>
-                <a:latin typeface="PingFang TC"/>
               </a:rPr>
-              <a:t>• 定向感障礙：</a:t>
-            </a:r>
-            <a:r>
-              <a:rPr sz="1100">
+              <a:t>★ 遺產繼承權最大利益：
+</a:t>
+            </a:r>
+            <a:r>
+              <a:rPr sz="1050">
                 <a:solidFill>
                   <a:srgbClr val="2D3748"/>
                 </a:solidFill>
-                <a:latin typeface="PingFang TC"/>
               </a:rPr>
-              <a:t>載明「人、時、地定向感顯著喪失（Disorientation）」。</a:t>
-            </a:r>
-          </a:p>
-          <a:p>
-            <a:pPr>
-              <a:spcBef>
-                <a:spcPts val="800"/>
-              </a:spcBef>
-            </a:pPr>
-            <a:r>
-              <a:rPr sz="1200" b="1">
-                <a:solidFill>
-                  <a:srgbClr val="D97706"/>
-                </a:solidFill>
-                <a:latin typeface="PingFang TC"/>
-              </a:rPr>
-              <a:t>• 記憶力缺損：</a:t>
-            </a:r>
-            <a:r>
-              <a:rPr sz="1100">
-                <a:solidFill>
-                  <a:srgbClr val="2D3748"/>
-                </a:solidFill>
-                <a:latin typeface="PingFang TC"/>
-              </a:rPr>
-              <a:t>載明「近期與遠期記憶力嚴重缺損，無法回憶重大生活事件」。</a:t>
-            </a:r>
-          </a:p>
-          <a:p>
-            <a:pPr>
-              <a:spcBef>
-                <a:spcPts val="800"/>
-              </a:spcBef>
-            </a:pPr>
-            <a:r>
-              <a:rPr sz="1200" b="1">
-                <a:solidFill>
-                  <a:srgbClr val="D97706"/>
-                </a:solidFill>
-                <a:latin typeface="PingFang TC"/>
-              </a:rPr>
-              <a:t>• 判斷力喪失：</a:t>
-            </a:r>
-            <a:r>
-              <a:rPr sz="1100">
-                <a:solidFill>
-                  <a:srgbClr val="2D3748"/>
-                </a:solidFill>
-                <a:latin typeface="PingFang TC"/>
-              </a:rPr>
-              <a:t>載明「判斷力、抽象思考與計算能力嚴重衰退」。</a:t>
-            </a:r>
-          </a:p>
-          <a:p>
-            <a:pPr>
-              <a:spcBef>
-                <a:spcPts val="800"/>
-              </a:spcBef>
-            </a:pPr>
-            <a:r>
-              <a:rPr sz="1200" b="1">
-                <a:solidFill>
-                  <a:srgbClr val="D97706"/>
-                </a:solidFill>
-                <a:latin typeface="PingFang TC"/>
-              </a:rPr>
-              <a:t>• 量表數據指標：</a:t>
-            </a:r>
-            <a:r>
-              <a:rPr sz="1100">
-                <a:solidFill>
-                  <a:srgbClr val="2D3748"/>
-                </a:solidFill>
-                <a:latin typeface="PingFang TC"/>
-              </a:rPr>
-              <a:t>務必載明「臨床失智評估量表（CDR）＝ X分」及 MMSE 測驗分數。</a:t>
+              <a:t>策略A堅決不同意離婚，母親死守第一順位繼承權；百年後先分一半再繼承，小三湛明輝一毛分不到！</a:t>
             </a:r>
           </a:p>
         </p:txBody>
@@ -3608,7 +3527,7 @@
           <a:solidFill>
             <a:srgbClr val="FFFBEB"/>
           </a:solidFill>
-          <a:ln w="19050">
+          <a:ln>
             <a:solidFill>
               <a:srgbClr val="DE5814"/>
             </a:solidFill>
@@ -3629,18 +3548,17 @@
           </a:fontRef>
         </p:style>
         <p:txBody>
-          <a:bodyPr rtlCol="0" anchor="ctr" wrap="square" lIns="274320" rIns="274320" tIns="274320"/>
+          <a:bodyPr rtlCol="0" anchor="ctr" wrap="square" lIns="228600" rIns="228600" tIns="228600"/>
           <a:lstStyle/>
           <a:p>
             <a:pPr algn="ctr"/>
             <a:r>
-              <a:rPr sz="1600" b="1">
+              <a:rPr b="1" sz="1600">
                 <a:solidFill>
                   <a:srgbClr val="DE5814"/>
                 </a:solidFill>
-                <a:latin typeface="PingFang TC"/>
               </a:rPr>
-              <a:t>二、法院審判高度採信之「法定關鍵用語」</a:t>
+              <a:t>二、財產黃金期：100% 全為婚後財產</a:t>
             </a:r>
           </a:p>
           <a:p>
@@ -3650,22 +3568,21 @@
               </a:spcBef>
             </a:pPr>
             <a:r>
-              <a:rPr sz="1200" b="1">
+              <a:rPr b="1" sz="1200">
                 <a:solidFill>
                   <a:srgbClr val="D97706"/>
                 </a:solidFill>
-                <a:latin typeface="PingFang TC"/>
               </a:rPr>
-              <a:t>★ 意思能力要件：</a:t>
-            </a:r>
-            <a:r>
-              <a:rPr sz="1100">
+              <a:t>★ 全落在民法74年後：
+</a:t>
+            </a:r>
+            <a:r>
+              <a:rPr sz="1050">
                 <a:solidFill>
                   <a:srgbClr val="2D3748"/>
                 </a:solidFill>
-                <a:latin typeface="PingFang TC"/>
               </a:rPr>
-              <a:t>載明「因精神障礙或心智缺陷，致不能為意思表示或受意思表示，已無處理自己事務之能力」。（民法第14條監護宣告鐵證）</a:t>
+              <a:t>置產買房、股票存款全在婚姻存續期間取得，無婚前財產可扣除，母親穩拿差額50%。</a:t>
             </a:r>
           </a:p>
           <a:p>
@@ -3675,22 +3592,21 @@
               </a:spcBef>
             </a:pPr>
             <a:r>
-              <a:rPr sz="1200" b="1">
+              <a:rPr b="1" sz="1200">
                 <a:solidFill>
                   <a:srgbClr val="D97706"/>
                 </a:solidFill>
-                <a:latin typeface="PingFang TC"/>
               </a:rPr>
-              <a:t>★ 阻斷私簽協議：</a:t>
-            </a:r>
-            <a:r>
-              <a:rPr sz="1100">
+              <a:t>★ 民法1030-3追加追討：
+</a:t>
+            </a:r>
+            <a:r>
+              <a:rPr sz="1050">
                 <a:solidFill>
                   <a:srgbClr val="2D3748"/>
                 </a:solidFill>
-                <a:latin typeface="PingFang TC"/>
               </a:rPr>
-              <a:t>確認「欠缺完全行為能力與事理辨識能力」，杜絕父親私下誘騙母親簽字離婚或將房產贈與脫產。</a:t>
+              <a:t>廖光輝過去5年內贈與、買房給湛明輝之資產，法律全數追加算回廖光輝資產總額！</a:t>
             </a:r>
           </a:p>
           <a:p>
@@ -3700,47 +3616,21 @@
               </a:spcBef>
             </a:pPr>
             <a:r>
-              <a:rPr sz="1200" b="1">
+              <a:rPr b="1" sz="1200">
                 <a:solidFill>
                   <a:srgbClr val="D97706"/>
                 </a:solidFill>
-                <a:latin typeface="PingFang TC"/>
               </a:rPr>
-              <a:t>★ 生活自理依賴：</a:t>
-            </a:r>
-            <a:r>
-              <a:rPr sz="1100">
+              <a:t>★ 判命湛明輝代為返還：
+</a:t>
+            </a:r>
+            <a:r>
+              <a:rPr sz="1050">
                 <a:solidFill>
                   <a:srgbClr val="2D3748"/>
                 </a:solidFill>
-                <a:latin typeface="PingFang TC"/>
               </a:rPr>
-              <a:t>載明「生活完全無法自理，需專人24小時全天候看護照料」。（爭取高額扶養費與贍養費必備）</a:t>
-            </a:r>
-          </a:p>
-          <a:p>
-            <a:pPr>
-              <a:spcBef>
-                <a:spcPts val="1000"/>
-              </a:spcBef>
-            </a:pPr>
-            <a:r>
-              <a:rPr sz="1200" b="1">
-                <a:solidFill>
-                  <a:srgbClr val="D97706"/>
-                </a:solidFill>
-                <a:latin typeface="PingFang TC"/>
-              </a:rPr>
-              <a:t>★ 病程不可逆性：</a:t>
-            </a:r>
-            <a:r>
-              <a:rPr sz="1100">
-                <a:solidFill>
-                  <a:srgbClr val="2D3748"/>
-                </a:solidFill>
-                <a:latin typeface="PingFang TC"/>
-              </a:rPr>
-              <a:t>載明「長期規則於神經內科診療，病況屬永久不可逆神經退化」。（證明母親無過失，駁回對方無理離婚訴請）</a:t>
+              <a:t>若廖光輝名下被掏空，法院依法直接判命受領人湛明輝將現金吐出來還給母親！</a:t>
             </a:r>
           </a:p>
         </p:txBody>
@@ -3825,7 +3715,7 @@
           <a:noFill/>
         </p:spPr>
         <p:txBody>
-          <a:bodyPr wrap="square" lIns="0" tIns="0" rIns="0" bIns="0">
+          <a:bodyPr wrap="square">
             <a:spAutoFit/>
           </a:bodyPr>
           <a:lstStyle/>
@@ -3837,7 +3727,7 @@
                 </a:solidFill>
                 <a:latin typeface="PingFang TC"/>
               </a:rPr>
-              <a:t>【醫療與社福】 </a:t>
+              <a:t>【司法程序】 </a:t>
             </a:r>
             <a:r>
               <a:rPr sz="2400" b="1">
@@ -3846,7 +3736,7 @@
                 </a:solidFill>
                 <a:latin typeface="PingFang TC"/>
               </a:rPr>
-              <a:t>台中榮總就診與身心障礙證明（殘障手冊）同步辦理</a:t>
+              <a:t>程序篇：法院訴訟與財產保全三大法定程序</a:t>
             </a:r>
           </a:p>
         </p:txBody>
@@ -3885,104 +3775,16 @@
           </a:p>
         </p:txBody>
       </p:sp>
-      <p:pic>
-        <p:nvPicPr>
-          <p:cNvPr id="5" name="Picture 4" descr="icon_ankh.png"/>
-          <p:cNvPicPr>
-            <a:picLocks noChangeAspect="1"/>
-          </p:cNvPicPr>
-          <p:nvPr/>
-        </p:nvPicPr>
-        <p:blipFill>
-          <a:blip r:embed="rId2"/>
-          <a:stretch>
-            <a:fillRect/>
-          </a:stretch>
-        </p:blipFill>
-        <p:spPr>
-          <a:xfrm>
-            <a:off x="9875520" y="1645920"/>
-            <a:ext cx="1645920" cy="1645920"/>
-          </a:xfrm>
-          <a:prstGeom prst="rect">
-            <a:avLst/>
-          </a:prstGeom>
-        </p:spPr>
-      </p:pic>
-      <p:sp>
-        <p:nvSpPr>
-          <p:cNvPr id="6" name="Rounded Rectangle 5"/>
+      <p:sp>
+        <p:nvSpPr>
+          <p:cNvPr id="5" name="Rounded Rectangle 4"/>
           <p:cNvSpPr/>
           <p:nvPr/>
         </p:nvSpPr>
         <p:spPr>
           <a:xfrm>
             <a:off x="731520" y="1463040"/>
-            <a:ext cx="8778240" cy="1417320"/>
-          </a:xfrm>
-          <a:prstGeom prst="roundRect">
-            <a:avLst/>
-          </a:prstGeom>
-          <a:solidFill>
-            <a:srgbClr val="FFFBEB"/>
-          </a:solidFill>
-          <a:ln>
-            <a:solidFill>
-              <a:srgbClr val="EA580C"/>
-            </a:solidFill>
-          </a:ln>
-        </p:spPr>
-        <p:style>
-          <a:lnRef idx="1">
-            <a:schemeClr val="accent1"/>
-          </a:lnRef>
-          <a:fillRef idx="3">
-            <a:schemeClr val="accent1"/>
-          </a:fillRef>
-          <a:effectRef idx="2">
-            <a:schemeClr val="accent1"/>
-          </a:effectRef>
-          <a:fontRef idx="minor">
-            <a:schemeClr val="lt1"/>
-          </a:fontRef>
-        </p:style>
-        <p:txBody>
-          <a:bodyPr rtlCol="0" anchor="ctr" wrap="square" lIns="182880" rIns="182880" tIns="182880"/>
-          <a:lstStyle/>
-          <a:p>
-            <a:pPr algn="ctr"/>
-            <a:r>
-              <a:rPr b="1" sz="1400">
-                <a:solidFill>
-                  <a:srgbClr val="A83212"/>
-                </a:solidFill>
-              </a:rPr>
-              <a:t>步驟一：看診前先至戶籍地區公所領取【身心障礙鑑定表】
-</a:t>
-            </a:r>
-          </a:p>
-          <a:p>
-            <a:r>
-              <a:rPr sz="1100">
-                <a:solidFill>
-                  <a:srgbClr val="2D3748"/>
-                </a:solidFill>
-              </a:rPr>
-              <a:t>攜帶證件：母親身分證正本、印章、1吋照片3張、代辦人身分證與印章。先領取空白表格，避免看診後再度折返。</a:t>
-            </a:r>
-          </a:p>
-        </p:txBody>
-      </p:sp>
-      <p:sp>
-        <p:nvSpPr>
-          <p:cNvPr id="7" name="Rounded Rectangle 6"/>
-          <p:cNvSpPr/>
-          <p:nvPr/>
-        </p:nvSpPr>
-        <p:spPr>
-          <a:xfrm>
-            <a:off x="731520" y="3017520"/>
-            <a:ext cx="8778240" cy="1417320"/>
+            <a:ext cx="10728655" cy="1371600"/>
           </a:xfrm>
           <a:prstGeom prst="roundRect">
             <a:avLst/>
@@ -4011,7 +3813,7 @@
           </a:fontRef>
         </p:style>
         <p:txBody>
-          <a:bodyPr rtlCol="0" anchor="ctr" wrap="square" lIns="182880" rIns="182880" tIns="182880"/>
+          <a:bodyPr rtlCol="0" anchor="ctr" wrap="square"/>
           <a:lstStyle/>
           <a:p>
             <a:pPr algn="ctr"/>
@@ -4021,7 +3823,7 @@
                   <a:srgbClr val="DE5814"/>
                 </a:solidFill>
               </a:rPr>
-              <a:t>步驟二：門診時交給醫師鑑定填寫，台中榮總院內專人送件
+              <a:t>程序一：家事法院【監護宣告】
 </a:t>
             </a:r>
           </a:p>
@@ -4032,21 +3834,21 @@
                   <a:srgbClr val="2D3748"/>
                 </a:solidFill>
               </a:rPr>
-              <a:t>同科其他神經內科醫師可直接調閱田怡婷醫師過去的電腦病歷、腦部影像及量表報告，直接完成生理鑑定；隨後移交第一醫療大樓大廳身障窗口完成生活評估並送件。</a:t>
-            </a:r>
-          </a:p>
-        </p:txBody>
-      </p:sp>
-      <p:sp>
-        <p:nvSpPr>
-          <p:cNvPr id="8" name="Rounded Rectangle 7"/>
+              <a:t>檢附榮總診斷書，由子女聲請監護宣告並出任法定代理人。徹底阻斷廖光輝誘騙母親私下簽署離婚或過戶切結書；未來所有訴訟由監護人代理。</a:t>
+            </a:r>
+          </a:p>
+        </p:txBody>
+      </p:sp>
+      <p:sp>
+        <p:nvSpPr>
+          <p:cNvPr id="6" name="Rounded Rectangle 5"/>
           <p:cNvSpPr/>
           <p:nvPr/>
         </p:nvSpPr>
         <p:spPr>
           <a:xfrm>
-            <a:off x="731520" y="4572000"/>
-            <a:ext cx="8778240" cy="1508760"/>
+            <a:off x="731520" y="3017520"/>
+            <a:ext cx="10728655" cy="1371600"/>
           </a:xfrm>
           <a:prstGeom prst="roundRect">
             <a:avLst/>
@@ -4056,7 +3858,7 @@
           </a:solidFill>
           <a:ln>
             <a:solidFill>
-              <a:srgbClr val="A83212"/>
+              <a:srgbClr val="D97706"/>
             </a:solidFill>
           </a:ln>
         </p:spPr>
@@ -4075,17 +3877,17 @@
           </a:fontRef>
         </p:style>
         <p:txBody>
-          <a:bodyPr rtlCol="0" anchor="ctr" wrap="square" lIns="182880" rIns="182880" tIns="182880"/>
+          <a:bodyPr rtlCol="0" anchor="ctr" wrap="square"/>
           <a:lstStyle/>
           <a:p>
             <a:pPr algn="ctr"/>
             <a:r>
               <a:rPr b="1" sz="1400">
                 <a:solidFill>
-                  <a:srgbClr val="A83212"/>
+                  <a:srgbClr val="DE5814"/>
                 </a:solidFill>
               </a:rPr>
-              <a:t>取得身心障礙證明之四大實質效益（與外勞資格完全加成）
+              <a:t>程序二：防範洗錢【假扣押與暫時處分】
 </a:t>
             </a:r>
           </a:p>
@@ -4096,7 +3898,71 @@
                   <a:srgbClr val="2D3748"/>
                 </a:solidFill>
               </a:rPr>
-              <a:t>1. 綜合所得稅特別扣除額 21.8 萬元/年  2. 健保自付額中度減半、重度全免  3. 專用車輛免徵牌照稅  4. 重度證明免繳外籍看護就業安定費（省 2,000元/月）。</a:t>
+              <a:t>聲請法院裁定查封廖光輝與湛明輝名下不動產與銀行帳戶，防範轉賣套現；同步裁定命廖光輝按月給付外籍看護月薪與醫療長照生活費。</a:t>
+            </a:r>
+          </a:p>
+        </p:txBody>
+      </p:sp>
+      <p:sp>
+        <p:nvSpPr>
+          <p:cNvPr id="7" name="Rounded Rectangle 6"/>
+          <p:cNvSpPr/>
+          <p:nvPr/>
+        </p:nvSpPr>
+        <p:spPr>
+          <a:xfrm>
+            <a:off x="731520" y="4572000"/>
+            <a:ext cx="10728655" cy="1371600"/>
+          </a:xfrm>
+          <a:prstGeom prst="roundRect">
+            <a:avLst/>
+          </a:prstGeom>
+          <a:solidFill>
+            <a:srgbClr val="FFFBEB"/>
+          </a:solidFill>
+          <a:ln>
+            <a:solidFill>
+              <a:srgbClr val="D97706"/>
+            </a:solidFill>
+          </a:ln>
+        </p:spPr>
+        <p:style>
+          <a:lnRef idx="1">
+            <a:schemeClr val="accent1"/>
+          </a:lnRef>
+          <a:fillRef idx="3">
+            <a:schemeClr val="accent1"/>
+          </a:fillRef>
+          <a:effectRef idx="2">
+            <a:schemeClr val="accent1"/>
+          </a:effectRef>
+          <a:fontRef idx="minor">
+            <a:schemeClr val="lt1"/>
+          </a:fontRef>
+        </p:style>
+        <p:txBody>
+          <a:bodyPr rtlCol="0" anchor="ctr" wrap="square"/>
+          <a:lstStyle/>
+          <a:p>
+            <a:pPr algn="ctr"/>
+            <a:r>
+              <a:rPr b="1" sz="1400">
+                <a:solidFill>
+                  <a:srgbClr val="DE5814"/>
+                </a:solidFill>
+              </a:rPr>
+              <a:t>程序三：實體裁判【反擊清算訴訟】
+</a:t>
+            </a:r>
+          </a:p>
+          <a:p>
+            <a:r>
+              <a:rPr sz="1100">
+                <a:solidFill>
+                  <a:srgbClr val="2D3748"/>
+                </a:solidFill>
+              </a:rPr>
+              <a:t>在家事法庭開庭時以民法1052條但書駁回離婚之訴；同步提起剩餘財產清算、追討湛明輝名下資產，並連帶求償侵害配偶權精神撫慰金。</a:t>
             </a:r>
           </a:p>
         </p:txBody>
@@ -4181,7 +4047,7 @@
           <a:noFill/>
         </p:spPr>
         <p:txBody>
-          <a:bodyPr wrap="square" lIns="0" tIns="0" rIns="0" bIns="0">
+          <a:bodyPr wrap="square">
             <a:spAutoFit/>
           </a:bodyPr>
           <a:lstStyle/>
@@ -4193,7 +4059,7 @@
                 </a:solidFill>
                 <a:latin typeface="PingFang TC"/>
               </a:rPr>
-              <a:t>【防禦止血】 </a:t>
+              <a:t>【實體求償】 </a:t>
             </a:r>
             <a:r>
               <a:rPr sz="2400" b="1">
@@ -4202,7 +4068,7 @@
                 </a:solidFill>
                 <a:latin typeface="PingFang TC"/>
               </a:rPr>
-              <a:t>第一階段：緊急法律防禦——監護宣告與財產凍結</a:t>
+              <a:t>方法篇：爭取權益與賠償金最大化四大實體方法</a:t>
             </a:r>
           </a:p>
         </p:txBody>
@@ -4241,402 +4107,471 @@
           </a:p>
         </p:txBody>
       </p:sp>
-      <p:pic>
-        <p:nvPicPr>
-          <p:cNvPr id="5" name="Picture 4" descr="icon_eye_horus.png"/>
-          <p:cNvPicPr>
-            <a:picLocks noChangeAspect="1"/>
-          </p:cNvPicPr>
+      <p:graphicFrame>
+        <p:nvGraphicFramePr>
+          <p:cNvPr id="5" name="Table 4"/>
+          <p:cNvGraphicFramePr>
+            <a:graphicFrameLocks noGrp="1"/>
+          </p:cNvGraphicFramePr>
           <p:nvPr/>
-        </p:nvPicPr>
-        <p:blipFill>
-          <a:blip r:embed="rId2"/>
-          <a:stretch>
-            <a:fillRect/>
-          </a:stretch>
-        </p:blipFill>
-        <p:spPr>
-          <a:xfrm>
-            <a:off x="10058400" y="548640"/>
-            <a:ext cx="1371600" cy="1371600"/>
-          </a:xfrm>
-          <a:prstGeom prst="rect">
-            <a:avLst/>
-          </a:prstGeom>
-        </p:spPr>
-      </p:pic>
-      <p:sp>
-        <p:nvSpPr>
-          <p:cNvPr id="6" name="Rounded Rectangle 5"/>
-          <p:cNvSpPr/>
-          <p:nvPr/>
-        </p:nvSpPr>
-        <p:spPr>
-          <a:xfrm>
-            <a:off x="731520" y="1463040"/>
-            <a:ext cx="3383280" cy="4572000"/>
-          </a:xfrm>
-          <a:prstGeom prst="roundRect">
-            <a:avLst/>
-          </a:prstGeom>
-          <a:solidFill>
-            <a:srgbClr val="FFFBEB"/>
-          </a:solidFill>
-          <a:ln w="19050">
-            <a:solidFill>
-              <a:srgbClr val="DE5814"/>
-            </a:solidFill>
-          </a:ln>
-        </p:spPr>
-        <p:style>
-          <a:lnRef idx="1">
-            <a:schemeClr val="accent1"/>
-          </a:lnRef>
-          <a:fillRef idx="3">
-            <a:schemeClr val="accent1"/>
-          </a:fillRef>
-          <a:effectRef idx="2">
-            <a:schemeClr val="accent1"/>
-          </a:effectRef>
-          <a:fontRef idx="minor">
-            <a:schemeClr val="lt1"/>
-          </a:fontRef>
-        </p:style>
-        <p:txBody>
-          <a:bodyPr rtlCol="0" anchor="ctr" wrap="square" lIns="228600" rIns="228600" tIns="228600"/>
-          <a:lstStyle/>
-          <a:p>
-            <a:pPr algn="ctr"/>
-            <a:r>
-              <a:rPr sz="1500" b="1">
-                <a:solidFill>
-                  <a:srgbClr val="DE5814"/>
-                </a:solidFill>
-              </a:rPr>
-              <a:t>1. 聲請「監護宣告」
-指派子女為法定監護人
-</a:t>
-            </a:r>
-          </a:p>
-          <a:p>
-            <a:pPr>
-              <a:spcBef>
-                <a:spcPts val="800"/>
-              </a:spcBef>
-            </a:pPr>
-            <a:r>
-              <a:rPr b="1" sz="1150">
-                <a:solidFill>
-                  <a:srgbClr val="D97706"/>
-                </a:solidFill>
-              </a:rPr>
-              <a:t>• 隔離父親操控：</a:t>
-            </a:r>
-            <a:r>
-              <a:rPr sz="1050">
-                <a:solidFill>
-                  <a:srgbClr val="2D3748"/>
-                </a:solidFill>
-              </a:rPr>
-              <a:t>母親已無法表達法律意志，由子女擔任法定代理人，阻絕任何私下簽署之風險。</a:t>
-            </a:r>
-          </a:p>
-          <a:p>
-            <a:pPr>
-              <a:spcBef>
-                <a:spcPts val="800"/>
-              </a:spcBef>
-            </a:pPr>
-            <a:r>
-              <a:rPr b="1" sz="1150">
-                <a:solidFill>
-                  <a:srgbClr val="D97706"/>
-                </a:solidFill>
-              </a:rPr>
-              <a:t>• 法定訴訟代理：</a:t>
-            </a:r>
-            <a:r>
-              <a:rPr sz="1050">
-                <a:solidFill>
-                  <a:srgbClr val="2D3748"/>
-                </a:solidFill>
-              </a:rPr>
-              <a:t>在後續所有離婚、分產官司中，均由監護人代表母親出庭捍衛權益。</a:t>
-            </a:r>
-          </a:p>
-          <a:p>
-            <a:pPr>
-              <a:spcBef>
-                <a:spcPts val="800"/>
-              </a:spcBef>
-            </a:pPr>
-            <a:r>
-              <a:rPr b="1" sz="1150">
-                <a:solidFill>
-                  <a:srgbClr val="D97706"/>
-                </a:solidFill>
-              </a:rPr>
-              <a:t>• 資產安全鎖定：</a:t>
-            </a:r>
-            <a:r>
-              <a:rPr sz="1050">
-                <a:solidFill>
-                  <a:srgbClr val="2D3748"/>
-                </a:solidFill>
-              </a:rPr>
-              <a:t>母親名下存摺、印鑑、房地產全數納入家事法院監管保護。</a:t>
-            </a:r>
-          </a:p>
-        </p:txBody>
-      </p:sp>
-      <p:sp>
-        <p:nvSpPr>
-          <p:cNvPr id="7" name="Rounded Rectangle 6"/>
-          <p:cNvSpPr/>
-          <p:nvPr/>
-        </p:nvSpPr>
-        <p:spPr>
-          <a:xfrm>
-            <a:off x="4389120" y="1463040"/>
-            <a:ext cx="3383280" cy="4572000"/>
-          </a:xfrm>
-          <a:prstGeom prst="roundRect">
-            <a:avLst/>
-          </a:prstGeom>
-          <a:solidFill>
-            <a:srgbClr val="FFFBEB"/>
-          </a:solidFill>
-          <a:ln w="19050">
-            <a:solidFill>
-              <a:srgbClr val="A83212"/>
-            </a:solidFill>
-          </a:ln>
-        </p:spPr>
-        <p:style>
-          <a:lnRef idx="1">
-            <a:schemeClr val="accent1"/>
-          </a:lnRef>
-          <a:fillRef idx="3">
-            <a:schemeClr val="accent1"/>
-          </a:fillRef>
-          <a:effectRef idx="2">
-            <a:schemeClr val="accent1"/>
-          </a:effectRef>
-          <a:fontRef idx="minor">
-            <a:schemeClr val="lt1"/>
-          </a:fontRef>
-        </p:style>
-        <p:txBody>
-          <a:bodyPr rtlCol="0" anchor="ctr" wrap="square" lIns="228600" rIns="228600" tIns="228600"/>
-          <a:lstStyle/>
-          <a:p>
-            <a:pPr algn="ctr"/>
-            <a:r>
-              <a:rPr sz="1500" b="1">
-                <a:solidFill>
-                  <a:srgbClr val="A83212"/>
-                </a:solidFill>
-              </a:rPr>
-              <a:t>2. 調閱國稅局清單
-全面清查父親資產底牌
-</a:t>
-            </a:r>
-          </a:p>
-          <a:p>
-            <a:pPr>
-              <a:spcBef>
-                <a:spcPts val="800"/>
-              </a:spcBef>
-            </a:pPr>
-            <a:r>
-              <a:rPr b="1" sz="1150">
-                <a:solidFill>
-                  <a:srgbClr val="D97706"/>
-                </a:solidFill>
-              </a:rPr>
-              <a:t>• 全國財產總歸戶：</a:t>
-            </a:r>
-            <a:r>
-              <a:rPr sz="1050">
-                <a:solidFill>
-                  <a:srgbClr val="2D3748"/>
-                </a:solidFill>
-              </a:rPr>
-              <a:t>調閱父親名下全部不動產（地號、建號、持分比例與公告現值）。</a:t>
-            </a:r>
-          </a:p>
-          <a:p>
-            <a:pPr>
-              <a:spcBef>
-                <a:spcPts val="800"/>
-              </a:spcBef>
-            </a:pPr>
-            <a:r>
-              <a:rPr b="1" sz="1150">
-                <a:solidFill>
-                  <a:srgbClr val="D97706"/>
-                </a:solidFill>
-              </a:rPr>
-              <a:t>• 近三年綜所稅清單：</a:t>
-            </a:r>
-            <a:r>
-              <a:rPr sz="1050">
-                <a:solidFill>
-                  <a:srgbClr val="2D3748"/>
-                </a:solidFill>
-              </a:rPr>
-              <a:t>查明大額銀行存款（從利息所得反推本金）及上市櫃股票股利明細。</a:t>
-            </a:r>
-          </a:p>
-          <a:p>
-            <a:pPr>
-              <a:spcBef>
-                <a:spcPts val="800"/>
-              </a:spcBef>
-            </a:pPr>
-            <a:r>
-              <a:rPr b="1" sz="1150">
-                <a:solidFill>
-                  <a:srgbClr val="D97706"/>
-                </a:solidFill>
-              </a:rPr>
-              <a:t>• 鎖定資產基數：</a:t>
-            </a:r>
-            <a:r>
-              <a:rPr sz="1050">
-                <a:solidFill>
-                  <a:srgbClr val="2D3748"/>
-                </a:solidFill>
-              </a:rPr>
-              <a:t>迅速掌握父親總身價，作為日後剩餘財產清算平分之法庭鐵證。</a:t>
-            </a:r>
-          </a:p>
-        </p:txBody>
-      </p:sp>
-      <p:sp>
-        <p:nvSpPr>
-          <p:cNvPr id="8" name="Rounded Rectangle 7"/>
-          <p:cNvSpPr/>
-          <p:nvPr/>
-        </p:nvSpPr>
-        <p:spPr>
-          <a:xfrm>
-            <a:off x="8046720" y="1463040"/>
-            <a:ext cx="3383280" cy="4572000"/>
-          </a:xfrm>
-          <a:prstGeom prst="roundRect">
-            <a:avLst/>
-          </a:prstGeom>
-          <a:solidFill>
-            <a:srgbClr val="FFFBEB"/>
-          </a:solidFill>
-          <a:ln w="19050">
-            <a:solidFill>
-              <a:srgbClr val="EA580C"/>
-            </a:solidFill>
-          </a:ln>
-        </p:spPr>
-        <p:style>
-          <a:lnRef idx="1">
-            <a:schemeClr val="accent1"/>
-          </a:lnRef>
-          <a:fillRef idx="3">
-            <a:schemeClr val="accent1"/>
-          </a:fillRef>
-          <a:effectRef idx="2">
-            <a:schemeClr val="accent1"/>
-          </a:effectRef>
-          <a:fontRef idx="minor">
-            <a:schemeClr val="lt1"/>
-          </a:fontRef>
-        </p:style>
-        <p:txBody>
-          <a:bodyPr rtlCol="0" anchor="ctr" wrap="square" lIns="228600" rIns="228600" tIns="228600"/>
-          <a:lstStyle/>
-          <a:p>
-            <a:pPr algn="ctr"/>
-            <a:r>
-              <a:rPr sz="1500" b="1">
-                <a:solidFill>
-                  <a:srgbClr val="EA580C"/>
-                </a:solidFill>
-              </a:rPr>
-              <a:t>3. 假扣押與暫時處分
-阻斷資產洗錢給小三
-</a:t>
-            </a:r>
-          </a:p>
-          <a:p>
-            <a:pPr>
-              <a:spcBef>
-                <a:spcPts val="800"/>
-              </a:spcBef>
-            </a:pPr>
-            <a:r>
-              <a:rPr b="1" sz="1150">
-                <a:solidFill>
-                  <a:srgbClr val="D97706"/>
-                </a:solidFill>
-              </a:rPr>
-              <a:t>• 財產保全假扣押：</a:t>
-            </a:r>
-            <a:r>
-              <a:rPr sz="1050">
-                <a:solidFill>
-                  <a:srgbClr val="2D3748"/>
-                </a:solidFill>
-              </a:rPr>
-              <a:t>查封凍結父親主要房產與高額銀行存款，禁止買賣、移轉或設定抵押。</a:t>
-            </a:r>
-          </a:p>
-          <a:p>
-            <a:pPr>
-              <a:spcBef>
-                <a:spcPts val="800"/>
-              </a:spcBef>
-            </a:pPr>
-            <a:r>
-              <a:rPr b="1" sz="1150">
-                <a:solidFill>
-                  <a:srgbClr val="D97706"/>
-                </a:solidFill>
-              </a:rPr>
-              <a:t>• 暫時處分扣生活費：</a:t>
-            </a:r>
-            <a:r>
-              <a:rPr sz="1050">
-                <a:solidFill>
-                  <a:srgbClr val="2D3748"/>
-                </a:solidFill>
-              </a:rPr>
-              <a:t>強制裁定父親在訴訟期間，按月支付母親外籍看護薪資與醫療開銷。</a:t>
-            </a:r>
-          </a:p>
-          <a:p>
-            <a:pPr>
-              <a:spcBef>
-                <a:spcPts val="800"/>
-              </a:spcBef>
-            </a:pPr>
-            <a:r>
-              <a:rPr b="1" sz="1150">
-                <a:solidFill>
-                  <a:srgbClr val="D97706"/>
-                </a:solidFill>
-              </a:rPr>
-              <a:t>• 破解惡意脫產：</a:t>
-            </a:r>
-            <a:r>
-              <a:rPr sz="1050">
-                <a:solidFill>
-                  <a:srgbClr val="2D3748"/>
-                </a:solidFill>
-              </a:rPr>
-              <a:t>即時凍結現場，防止父親藉由假借貸、轉帳、買車買房贈與第三者。</a:t>
-            </a:r>
-          </a:p>
-        </p:txBody>
-      </p:sp>
+        </p:nvGraphicFramePr>
+        <p:xfrm>
+          <a:off x="731520" y="1463040"/>
+          <a:ext cx="10728655" cy="4663440"/>
+        </p:xfrm>
+        <a:graphic>
+          <a:graphicData uri="http://schemas.openxmlformats.org/drawingml/2006/table">
+            <a:tbl>
+              <a:tblPr firstRow="1" bandRow="1">
+                <a:tableStyleId>{5C22544A-7EE6-4342-B048-85BDC9FD1C3A}</a:tableStyleId>
+              </a:tblPr>
+              <a:tblGrid>
+                <a:gridCol w="2011680"/>
+                <a:gridCol w="2103120"/>
+                <a:gridCol w="4023360"/>
+                <a:gridCol w="2590495"/>
+              </a:tblGrid>
+              <a:tr h="932688">
+                <a:tc>
+                  <a:txBody>
+                    <a:bodyPr/>
+                    <a:lstStyle/>
+                    <a:p>
+                      <a:r>
+                        <a:rPr b="1" sz="1300">
+                          <a:solidFill>
+                            <a:srgbClr val="A83212"/>
+                          </a:solidFill>
+                        </a:rPr>
+                        <a:t>求償方法</a:t>
+                      </a:r>
+                    </a:p>
+                  </a:txBody>
+                  <a:tcPr>
+                    <a:solidFill>
+                      <a:srgbClr val="FEF3C7"/>
+                    </a:solidFill>
+                  </a:tcPr>
+                </a:tc>
+                <a:tc>
+                  <a:txBody>
+                    <a:bodyPr/>
+                    <a:lstStyle/>
+                    <a:p>
+                      <a:r>
+                        <a:rPr b="1" sz="1300">
+                          <a:solidFill>
+                            <a:srgbClr val="A83212"/>
+                          </a:solidFill>
+                        </a:rPr>
+                        <a:t>民法條文</a:t>
+                      </a:r>
+                    </a:p>
+                  </a:txBody>
+                  <a:tcPr>
+                    <a:solidFill>
+                      <a:srgbClr val="FEF3C7"/>
+                    </a:solidFill>
+                  </a:tcPr>
+                </a:tc>
+                <a:tc>
+                  <a:txBody>
+                    <a:bodyPr/>
+                    <a:lstStyle/>
+                    <a:p>
+                      <a:r>
+                        <a:rPr b="1" sz="1300">
+                          <a:solidFill>
+                            <a:srgbClr val="A83212"/>
+                          </a:solidFill>
+                        </a:rPr>
+                        <a:t>求償內涵與法理策略</a:t>
+                      </a:r>
+                    </a:p>
+                  </a:txBody>
+                  <a:tcPr>
+                    <a:solidFill>
+                      <a:srgbClr val="FEF3C7"/>
+                    </a:solidFill>
+                  </a:tcPr>
+                </a:tc>
+                <a:tc>
+                  <a:txBody>
+                    <a:bodyPr/>
+                    <a:lstStyle/>
+                    <a:p>
+                      <a:r>
+                        <a:rPr b="1" sz="1300">
+                          <a:solidFill>
+                            <a:srgbClr val="A83212"/>
+                          </a:solidFill>
+                        </a:rPr>
+                        <a:t>預估效益與戰略定位</a:t>
+                      </a:r>
+                    </a:p>
+                  </a:txBody>
+                  <a:tcPr>
+                    <a:solidFill>
+                      <a:srgbClr val="FEF3C7"/>
+                    </a:solidFill>
+                  </a:tcPr>
+                </a:tc>
+              </a:tr>
+              <a:tr h="932688">
+                <a:tc>
+                  <a:txBody>
+                    <a:bodyPr/>
+                    <a:lstStyle/>
+                    <a:p>
+                      <a:r>
+                        <a:rPr sz="1050" b="1">
+                          <a:solidFill>
+                            <a:srgbClr val="DE5814"/>
+                          </a:solidFill>
+                        </a:rPr>
+                        <a:t>一、夫妻剩餘財產分配請求權</a:t>
+                      </a:r>
+                    </a:p>
+                  </a:txBody>
+                  <a:tcPr>
+                    <a:solidFill>
+                      <a:srgbClr val="FFFFFF"/>
+                    </a:solidFill>
+                  </a:tcPr>
+                </a:tc>
+                <a:tc>
+                  <a:txBody>
+                    <a:bodyPr/>
+                    <a:lstStyle/>
+                    <a:p>
+                      <a:r>
+                        <a:rPr sz="1050">
+                          <a:solidFill>
+                            <a:srgbClr val="2D3748"/>
+                          </a:solidFill>
+                        </a:rPr>
+                        <a:t>民法第 1030 條之 1</a:t>
+                      </a:r>
+                    </a:p>
+                  </a:txBody>
+                  <a:tcPr>
+                    <a:solidFill>
+                      <a:srgbClr val="FFFFFF"/>
+                    </a:solidFill>
+                  </a:tcPr>
+                </a:tc>
+                <a:tc>
+                  <a:txBody>
+                    <a:bodyPr/>
+                    <a:lstStyle/>
+                    <a:p>
+                      <a:r>
+                        <a:rPr sz="1050">
+                          <a:solidFill>
+                            <a:srgbClr val="2D3748"/>
+                          </a:solidFill>
+                        </a:rPr>
+                        <a:t>清查雙方現存婚後財產扣除負債後差額平均分配。五十年婚姻積累之房地產與存款，母親依法享有差額 50% 請求權。</a:t>
+                      </a:r>
+                    </a:p>
+                  </a:txBody>
+                  <a:tcPr>
+                    <a:solidFill>
+                      <a:srgbClr val="FFFFFF"/>
+                    </a:solidFill>
+                  </a:tcPr>
+                </a:tc>
+                <a:tc>
+                  <a:txBody>
+                    <a:bodyPr/>
+                    <a:lstStyle/>
+                    <a:p>
+                      <a:r>
+                        <a:rPr sz="1050" b="1">
+                          <a:solidFill>
+                            <a:srgbClr val="A83212"/>
+                          </a:solidFill>
+                        </a:rPr>
+                        <a:t>【金額最大宗・佔90%以上】
+數百萬至數千萬元法定產權，為母親晚年生活最堅實保障。</a:t>
+                      </a:r>
+                    </a:p>
+                  </a:txBody>
+                  <a:tcPr>
+                    <a:solidFill>
+                      <a:srgbClr val="FFFFFF"/>
+                    </a:solidFill>
+                  </a:tcPr>
+                </a:tc>
+              </a:tr>
+              <a:tr h="932688">
+                <a:tc>
+                  <a:txBody>
+                    <a:bodyPr/>
+                    <a:lstStyle/>
+                    <a:p>
+                      <a:r>
+                        <a:rPr sz="1050" b="1">
+                          <a:solidFill>
+                            <a:srgbClr val="DE5814"/>
+                          </a:solidFill>
+                        </a:rPr>
+                        <a:t>二、追討第三者條款（追加計算）</a:t>
+                      </a:r>
+                    </a:p>
+                  </a:txBody>
+                  <a:tcPr>
+                    <a:solidFill>
+                      <a:srgbClr val="FFFDF7"/>
+                    </a:solidFill>
+                  </a:tcPr>
+                </a:tc>
+                <a:tc>
+                  <a:txBody>
+                    <a:bodyPr/>
+                    <a:lstStyle/>
+                    <a:p>
+                      <a:r>
+                        <a:rPr sz="1050">
+                          <a:solidFill>
+                            <a:srgbClr val="2D3748"/>
+                          </a:solidFill>
+                        </a:rPr>
+                        <a:t>民法第 1030 條之 3
+民法第 1020 條之 1</a:t>
+                      </a:r>
+                    </a:p>
+                  </a:txBody>
+                  <a:tcPr>
+                    <a:solidFill>
+                      <a:srgbClr val="FFFDF7"/>
+                    </a:solidFill>
+                  </a:tcPr>
+                </a:tc>
+                <a:tc>
+                  <a:txBody>
+                    <a:bodyPr/>
+                    <a:lstStyle/>
+                    <a:p>
+                      <a:r>
+                        <a:rPr sz="1050">
+                          <a:solidFill>
+                            <a:srgbClr val="2D3748"/>
+                          </a:solidFill>
+                        </a:rPr>
+                        <a:t>起訴前五年內，廖光輝為減少分配無償移轉予湛明輝之資產，全數追加計算為廖光輝現存財產！若不夠返還，法院直接判命「湛明輝代為吐出差額返還母親」！一年內贈與更得直接訴請撤銷。</a:t>
+                      </a:r>
+                    </a:p>
+                  </a:txBody>
+                  <a:tcPr>
+                    <a:solidFill>
+                      <a:srgbClr val="FFFDF7"/>
+                    </a:solidFill>
+                  </a:tcPr>
+                </a:tc>
+                <a:tc>
+                  <a:txBody>
+                    <a:bodyPr/>
+                    <a:lstStyle/>
+                    <a:p>
+                      <a:r>
+                        <a:rPr sz="1050" b="1">
+                          <a:solidFill>
+                            <a:srgbClr val="A83212"/>
+                          </a:solidFill>
+                        </a:rPr>
+                        <a:t>【破解脫產殺手鐧】
+搬給湛明輝的現金房產全數追回計入，讓第三者白忙一場。</a:t>
+                      </a:r>
+                    </a:p>
+                  </a:txBody>
+                  <a:tcPr>
+                    <a:solidFill>
+                      <a:srgbClr val="FFFDF7"/>
+                    </a:solidFill>
+                  </a:tcPr>
+                </a:tc>
+              </a:tr>
+              <a:tr h="932688">
+                <a:tc>
+                  <a:txBody>
+                    <a:bodyPr/>
+                    <a:lstStyle/>
+                    <a:p>
+                      <a:r>
+                        <a:rPr sz="1050" b="1">
+                          <a:solidFill>
+                            <a:srgbClr val="DE5814"/>
+                          </a:solidFill>
+                        </a:rPr>
+                        <a:t>三、侵害配偶權連帶精神撫慰金</a:t>
+                      </a:r>
+                    </a:p>
+                  </a:txBody>
+                  <a:tcPr>
+                    <a:solidFill>
+                      <a:srgbClr val="FFFFFF"/>
+                    </a:solidFill>
+                  </a:tcPr>
+                </a:tc>
+                <a:tc>
+                  <a:txBody>
+                    <a:bodyPr/>
+                    <a:lstStyle/>
+                    <a:p>
+                      <a:r>
+                        <a:rPr sz="1050">
+                          <a:solidFill>
+                            <a:srgbClr val="2D3748"/>
+                          </a:solidFill>
+                        </a:rPr>
+                        <a:t>民法第 184 條
+民法第 195 條第 3 項</a:t>
+                      </a:r>
+                    </a:p>
+                  </a:txBody>
+                  <a:tcPr>
+                    <a:solidFill>
+                      <a:srgbClr val="FFFFFF"/>
+                    </a:solidFill>
+                  </a:tcPr>
+                </a:tc>
+                <a:tc>
+                  <a:txBody>
+                    <a:bodyPr/>
+                    <a:lstStyle/>
+                    <a:p>
+                      <a:r>
+                        <a:rPr sz="1050">
+                          <a:solidFill>
+                            <a:srgbClr val="2D3748"/>
+                          </a:solidFill>
+                        </a:rPr>
+                        <a:t>共同提告廖光輝與湛明輝為連帶共同被告。舉證兩人同居出入、親暱對話。審酌母親八旬重病遭背叛之重大痛苦，判令兩人連帶賠償。</a:t>
+                      </a:r>
+                    </a:p>
+                  </a:txBody>
+                  <a:tcPr>
+                    <a:solidFill>
+                      <a:srgbClr val="FFFFFF"/>
+                    </a:solidFill>
+                  </a:tcPr>
+                </a:tc>
+                <a:tc>
+                  <a:txBody>
+                    <a:bodyPr/>
+                    <a:lstStyle/>
+                    <a:p>
+                      <a:r>
+                        <a:rPr sz="1050" b="1">
+                          <a:solidFill>
+                            <a:srgbClr val="A83212"/>
+                          </a:solidFill>
+                        </a:rPr>
+                        <a:t>【直擊第三者連帶賠償】
+實務判賠金額普遍落於 60 萬 ～ 100 萬元。</a:t>
+                      </a:r>
+                    </a:p>
+                  </a:txBody>
+                  <a:tcPr>
+                    <a:solidFill>
+                      <a:srgbClr val="FFFFFF"/>
+                    </a:solidFill>
+                  </a:tcPr>
+                </a:tc>
+              </a:tr>
+              <a:tr h="932688">
+                <a:tc>
+                  <a:txBody>
+                    <a:bodyPr/>
+                    <a:lstStyle/>
+                    <a:p>
+                      <a:r>
+                        <a:rPr sz="1050" b="1">
+                          <a:solidFill>
+                            <a:srgbClr val="DE5814"/>
+                          </a:solidFill>
+                        </a:rPr>
+                        <a:t>四、離婚損害賠償與終身贍養費</a:t>
+                      </a:r>
+                    </a:p>
+                  </a:txBody>
+                  <a:tcPr>
+                    <a:solidFill>
+                      <a:srgbClr val="FFFDF7"/>
+                    </a:solidFill>
+                  </a:tcPr>
+                </a:tc>
+                <a:tc>
+                  <a:txBody>
+                    <a:bodyPr/>
+                    <a:lstStyle/>
+                    <a:p>
+                      <a:r>
+                        <a:rPr sz="1050">
+                          <a:solidFill>
+                            <a:srgbClr val="2D3748"/>
+                          </a:solidFill>
+                        </a:rPr>
+                        <a:t>民法第 1056 條
+民法第 1057 條</a:t>
+                      </a:r>
+                    </a:p>
+                  </a:txBody>
+                  <a:tcPr>
+                    <a:solidFill>
+                      <a:srgbClr val="FFFDF7"/>
+                    </a:solidFill>
+                  </a:tcPr>
+                </a:tc>
+                <a:tc>
+                  <a:txBody>
+                    <a:bodyPr/>
+                    <a:lstStyle/>
+                    <a:p>
+                      <a:r>
+                        <a:rPr sz="1050">
+                          <a:solidFill>
+                            <a:srgbClr val="2D3748"/>
+                          </a:solidFill>
+                        </a:rPr>
+                        <a:t>判決離婚非財產損害賠償（20萬~80萬）；加計母親八旬失智、無謀生能力，判命廖光輝按月全額給付外籍看護薪資（約3.5萬）與終身照護費，或一次性提撥數百萬贍養基金。</a:t>
+                      </a:r>
+                    </a:p>
+                  </a:txBody>
+                  <a:tcPr>
+                    <a:solidFill>
+                      <a:srgbClr val="FFFDF7"/>
+                    </a:solidFill>
+                  </a:tcPr>
+                </a:tc>
+                <a:tc>
+                  <a:txBody>
+                    <a:bodyPr/>
+                    <a:lstStyle/>
+                    <a:p>
+                      <a:r>
+                        <a:rPr sz="1050" b="1">
+                          <a:solidFill>
+                            <a:srgbClr val="A83212"/>
+                          </a:solidFill>
+                        </a:rPr>
+                        <a:t>【終身全額保障尊嚴】
+外籍看護月薪與安養醫療費由男方全額埋單。</a:t>
+                      </a:r>
+                    </a:p>
+                  </a:txBody>
+                  <a:tcPr>
+                    <a:solidFill>
+                      <a:srgbClr val="FFFDF7"/>
+                    </a:solidFill>
+                  </a:tcPr>
+                </a:tc>
+              </a:tr>
+            </a:tbl>
+          </a:graphicData>
+        </a:graphic>
+      </p:graphicFrame>
     </p:spTree>
   </p:cSld>
   <p:clrMapOvr>
@@ -4717,7 +4652,7 @@
           <a:noFill/>
         </p:spPr>
         <p:txBody>
-          <a:bodyPr wrap="square" lIns="0" tIns="0" rIns="0" bIns="0">
+          <a:bodyPr wrap="square">
             <a:spAutoFit/>
           </a:bodyPr>
           <a:lstStyle/>
@@ -4729,7 +4664,7 @@
                 </a:solidFill>
                 <a:latin typeface="PingFang TC"/>
               </a:rPr>
-              <a:t>【訴訟求償】 </a:t>
+              <a:t>【行動步驟】 </a:t>
             </a:r>
             <a:r>
               <a:rPr sz="2400" b="1">
@@ -4738,7 +4673,7 @@
                 </a:solidFill>
                 <a:latin typeface="PingFang TC"/>
               </a:rPr>
-              <a:t>第二階段：爭取母親權益最大化——四大核心金錢請求</a:t>
+              <a:t>步驟篇：家屬即刻行動指南與實施六大步驟（SOP）</a:t>
             </a:r>
           </a:p>
         </p:txBody>
@@ -4777,550 +4712,22 @@
           </a:p>
         </p:txBody>
       </p:sp>
-      <p:pic>
-        <p:nvPicPr>
-          <p:cNvPr id="5" name="Picture 4" descr="icon_scales.png"/>
-          <p:cNvPicPr>
-            <a:picLocks noChangeAspect="1"/>
-          </p:cNvPicPr>
+      <p:sp>
+        <p:nvSpPr>
+          <p:cNvPr id="5" name="Rounded Rectangle 4"/>
+          <p:cNvSpPr/>
           <p:nvPr/>
-        </p:nvPicPr>
-        <p:blipFill>
-          <a:blip r:embed="rId2"/>
-          <a:stretch>
-            <a:fillRect/>
-          </a:stretch>
-        </p:blipFill>
+        </p:nvSpPr>
         <p:spPr>
           <a:xfrm>
-            <a:off x="10241280" y="457200"/>
-            <a:ext cx="1371600" cy="1371600"/>
+            <a:off x="731520" y="1463040"/>
+            <a:ext cx="10728655" cy="713232"/>
           </a:xfrm>
-          <a:prstGeom prst="rect">
-            <a:avLst/>
-          </a:prstGeom>
-        </p:spPr>
-      </p:pic>
-      <p:graphicFrame>
-        <p:nvGraphicFramePr>
-          <p:cNvPr id="6" name="Table 5"/>
-          <p:cNvGraphicFramePr>
-            <a:graphicFrameLocks noGrp="1"/>
-          </p:cNvGraphicFramePr>
-          <p:nvPr/>
-        </p:nvGraphicFramePr>
-        <p:xfrm>
-          <a:off x="731520" y="1463040"/>
-          <a:ext cx="10728655" cy="4663440"/>
-        </p:xfrm>
-        <a:graphic>
-          <a:graphicData uri="http://schemas.openxmlformats.org/drawingml/2006/table">
-            <a:tbl>
-              <a:tblPr firstRow="1" bandRow="1">
-                <a:tableStyleId>{5C22544A-7EE6-4342-B048-85BDC9FD1C3A}</a:tableStyleId>
-              </a:tblPr>
-              <a:tblGrid>
-                <a:gridCol w="2011680"/>
-                <a:gridCol w="2194560"/>
-                <a:gridCol w="3931920"/>
-                <a:gridCol w="2590495"/>
-              </a:tblGrid>
-              <a:tr h="932688">
-                <a:tc>
-                  <a:txBody>
-                    <a:bodyPr/>
-                    <a:lstStyle/>
-                    <a:p>
-                      <a:r>
-                        <a:rPr sz="1300" b="1">
-                          <a:solidFill>
-                            <a:srgbClr val="A83212"/>
-                          </a:solidFill>
-                          <a:latin typeface="PingFang TC"/>
-                        </a:rPr>
-                        <a:t>求償項目</a:t>
-                      </a:r>
-                    </a:p>
-                  </a:txBody>
-                  <a:tcPr>
-                    <a:solidFill>
-                      <a:srgbClr val="FEF3C7"/>
-                    </a:solidFill>
-                  </a:tcPr>
-                </a:tc>
-                <a:tc>
-                  <a:txBody>
-                    <a:bodyPr/>
-                    <a:lstStyle/>
-                    <a:p>
-                      <a:r>
-                        <a:rPr sz="1300" b="1">
-                          <a:solidFill>
-                            <a:srgbClr val="A83212"/>
-                          </a:solidFill>
-                          <a:latin typeface="PingFang TC"/>
-                        </a:rPr>
-                        <a:t>法定依據</a:t>
-                      </a:r>
-                    </a:p>
-                  </a:txBody>
-                  <a:tcPr>
-                    <a:solidFill>
-                      <a:srgbClr val="FEF3C7"/>
-                    </a:solidFill>
-                  </a:tcPr>
-                </a:tc>
-                <a:tc>
-                  <a:txBody>
-                    <a:bodyPr/>
-                    <a:lstStyle/>
-                    <a:p>
-                      <a:r>
-                        <a:rPr sz="1300" b="1">
-                          <a:solidFill>
-                            <a:srgbClr val="A83212"/>
-                          </a:solidFill>
-                          <a:latin typeface="PingFang TC"/>
-                        </a:rPr>
-                        <a:t>求償內涵與法理策略</a:t>
-                      </a:r>
-                    </a:p>
-                  </a:txBody>
-                  <a:tcPr>
-                    <a:solidFill>
-                      <a:srgbClr val="FEF3C7"/>
-                    </a:solidFill>
-                  </a:tcPr>
-                </a:tc>
-                <a:tc>
-                  <a:txBody>
-                    <a:bodyPr/>
-                    <a:lstStyle/>
-                    <a:p>
-                      <a:r>
-                        <a:rPr sz="1300" b="1">
-                          <a:solidFill>
-                            <a:srgbClr val="A83212"/>
-                          </a:solidFill>
-                          <a:latin typeface="PingFang TC"/>
-                        </a:rPr>
-                        <a:t>預估效益與實戰定位</a:t>
-                      </a:r>
-                    </a:p>
-                  </a:txBody>
-                  <a:tcPr>
-                    <a:solidFill>
-                      <a:srgbClr val="FEF3C7"/>
-                    </a:solidFill>
-                  </a:tcPr>
-                </a:tc>
-              </a:tr>
-              <a:tr h="932688">
-                <a:tc>
-                  <a:txBody>
-                    <a:bodyPr/>
-                    <a:lstStyle/>
-                    <a:p>
-                      <a:r>
-                        <a:rPr sz="1050" b="1">
-                          <a:solidFill>
-                            <a:srgbClr val="DE5814"/>
-                          </a:solidFill>
-                          <a:latin typeface="PingFang TC"/>
-                        </a:rPr>
-                        <a:t>夫妻剩餘財產分配</a:t>
-                      </a:r>
-                    </a:p>
-                  </a:txBody>
-                  <a:tcPr>
-                    <a:solidFill>
-                      <a:srgbClr val="FFFFFF"/>
-                    </a:solidFill>
-                  </a:tcPr>
-                </a:tc>
-                <a:tc>
-                  <a:txBody>
-                    <a:bodyPr/>
-                    <a:lstStyle/>
-                    <a:p>
-                      <a:r>
-                        <a:rPr sz="1050">
-                          <a:solidFill>
-                            <a:srgbClr val="2D3748"/>
-                          </a:solidFill>
-                          <a:latin typeface="PingFang TC"/>
-                        </a:rPr>
-                        <a:t>民法第 1030 條之 1</a:t>
-                      </a:r>
-                    </a:p>
-                  </a:txBody>
-                  <a:tcPr>
-                    <a:solidFill>
-                      <a:srgbClr val="FFFFFF"/>
-                    </a:solidFill>
-                  </a:tcPr>
-                </a:tc>
-                <a:tc>
-                  <a:txBody>
-                    <a:bodyPr/>
-                    <a:lstStyle/>
-                    <a:p>
-                      <a:r>
-                        <a:rPr sz="1050">
-                          <a:solidFill>
-                            <a:srgbClr val="2D3748"/>
-                          </a:solidFill>
-                          <a:latin typeface="PingFang TC"/>
-                        </a:rPr>
-                        <a:t>清查雙方婚後增加財產淨額，扣除負債後差額平均分配。八十歲累積房產與存款多屬婚後所得，母親依法分得一半。</a:t>
-                      </a:r>
-                    </a:p>
-                  </a:txBody>
-                  <a:tcPr>
-                    <a:solidFill>
-                      <a:srgbClr val="FFFFFF"/>
-                    </a:solidFill>
-                  </a:tcPr>
-                </a:tc>
-                <a:tc>
-                  <a:txBody>
-                    <a:bodyPr/>
-                    <a:lstStyle/>
-                    <a:p>
-                      <a:r>
-                        <a:rPr sz="1050" b="1">
-                          <a:solidFill>
-                            <a:srgbClr val="A83212"/>
-                          </a:solidFill>
-                          <a:latin typeface="PingFang TC"/>
-                        </a:rPr>
-                        <a:t>【金額最大宗・佔90%以上】
-數百萬至數千萬元不等之法定產權。</a:t>
-                      </a:r>
-                    </a:p>
-                  </a:txBody>
-                  <a:tcPr>
-                    <a:solidFill>
-                      <a:srgbClr val="FFFFFF"/>
-                    </a:solidFill>
-                  </a:tcPr>
-                </a:tc>
-              </a:tr>
-              <a:tr h="932688">
-                <a:tc>
-                  <a:txBody>
-                    <a:bodyPr/>
-                    <a:lstStyle/>
-                    <a:p>
-                      <a:r>
-                        <a:rPr sz="1050" b="1">
-                          <a:solidFill>
-                            <a:srgbClr val="DE5814"/>
-                          </a:solidFill>
-                          <a:latin typeface="PingFang TC"/>
-                        </a:rPr>
-                        <a:t>追討第三者條款</a:t>
-                      </a:r>
-                    </a:p>
-                  </a:txBody>
-                  <a:tcPr>
-                    <a:solidFill>
-                      <a:srgbClr val="FFFDF7"/>
-                    </a:solidFill>
-                  </a:tcPr>
-                </a:tc>
-                <a:tc>
-                  <a:txBody>
-                    <a:bodyPr/>
-                    <a:lstStyle/>
-                    <a:p>
-                      <a:r>
-                        <a:rPr sz="1050">
-                          <a:solidFill>
-                            <a:srgbClr val="2D3748"/>
-                          </a:solidFill>
-                          <a:latin typeface="PingFang TC"/>
-                        </a:rPr>
-                        <a:t>民法第 1030 條之 3
-民法第 1020 條之 1</a:t>
-                      </a:r>
-                    </a:p>
-                  </a:txBody>
-                  <a:tcPr>
-                    <a:solidFill>
-                      <a:srgbClr val="FFFDF7"/>
-                    </a:solidFill>
-                  </a:tcPr>
-                </a:tc>
-                <a:tc>
-                  <a:txBody>
-                    <a:bodyPr/>
-                    <a:lstStyle/>
-                    <a:p>
-                      <a:r>
-                        <a:rPr sz="1050">
-                          <a:solidFill>
-                            <a:srgbClr val="2D3748"/>
-                          </a:solidFill>
-                          <a:latin typeface="PingFang TC"/>
-                        </a:rPr>
-                        <a:t>起訴前五年內，父親為減少分配而惡意贈與第三者之資產，全數「追加計算」為婚後財產！一年內無償贈與可直接訴請撤銷。</a:t>
-                      </a:r>
-                    </a:p>
-                  </a:txBody>
-                  <a:tcPr>
-                    <a:solidFill>
-                      <a:srgbClr val="FFFDF7"/>
-                    </a:solidFill>
-                  </a:tcPr>
-                </a:tc>
-                <a:tc>
-                  <a:txBody>
-                    <a:bodyPr/>
-                    <a:lstStyle/>
-                    <a:p>
-                      <a:r>
-                        <a:rPr sz="1050" b="1">
-                          <a:solidFill>
-                            <a:srgbClr val="A83212"/>
-                          </a:solidFill>
-                          <a:latin typeface="PingFang TC"/>
-                        </a:rPr>
-                        <a:t>【防止暗渡陳倉殺手鐧】
-轉移給小三的現金房產全數追回計入。</a:t>
-                      </a:r>
-                    </a:p>
-                  </a:txBody>
-                  <a:tcPr>
-                    <a:solidFill>
-                      <a:srgbClr val="FFFDF7"/>
-                    </a:solidFill>
-                  </a:tcPr>
-                </a:tc>
-              </a:tr>
-              <a:tr h="932688">
-                <a:tc>
-                  <a:txBody>
-                    <a:bodyPr/>
-                    <a:lstStyle/>
-                    <a:p>
-                      <a:r>
-                        <a:rPr sz="1050" b="1">
-                          <a:solidFill>
-                            <a:srgbClr val="DE5814"/>
-                          </a:solidFill>
-                          <a:latin typeface="PingFang TC"/>
-                        </a:rPr>
-                        <a:t>侵害配偶權賠償</a:t>
-                      </a:r>
-                    </a:p>
-                  </a:txBody>
-                  <a:tcPr>
-                    <a:solidFill>
-                      <a:srgbClr val="FFFFFF"/>
-                    </a:solidFill>
-                  </a:tcPr>
-                </a:tc>
-                <a:tc>
-                  <a:txBody>
-                    <a:bodyPr/>
-                    <a:lstStyle/>
-                    <a:p>
-                      <a:r>
-                        <a:rPr sz="1050">
-                          <a:solidFill>
-                            <a:srgbClr val="2D3748"/>
-                          </a:solidFill>
-                          <a:latin typeface="PingFang TC"/>
-                        </a:rPr>
-                        <a:t>民法第 184 條
-民法第 195 條第 3 項</a:t>
-                      </a:r>
-                    </a:p>
-                  </a:txBody>
-                  <a:tcPr>
-                    <a:solidFill>
-                      <a:srgbClr val="FFFFFF"/>
-                    </a:solidFill>
-                  </a:tcPr>
-                </a:tc>
-                <a:tc>
-                  <a:txBody>
-                    <a:bodyPr/>
-                    <a:lstStyle/>
-                    <a:p>
-                      <a:r>
-                        <a:rPr sz="1050">
-                          <a:solidFill>
-                            <a:srgbClr val="2D3748"/>
-                          </a:solidFill>
-                          <a:latin typeface="PingFang TC"/>
-                        </a:rPr>
-                        <a:t>將父親與小三列為連帶共同被告。舉證兩人親密交往破壞婚姻，審酌原配重病遭背叛之重大痛苦，判令連帶賠償精神慰撫金。</a:t>
-                      </a:r>
-                    </a:p>
-                  </a:txBody>
-                  <a:tcPr>
-                    <a:solidFill>
-                      <a:srgbClr val="FFFFFF"/>
-                    </a:solidFill>
-                  </a:tcPr>
-                </a:tc>
-                <a:tc>
-                  <a:txBody>
-                    <a:bodyPr/>
-                    <a:lstStyle/>
-                    <a:p>
-                      <a:r>
-                        <a:rPr sz="1050" b="1">
-                          <a:solidFill>
-                            <a:srgbClr val="A83212"/>
-                          </a:solidFill>
-                          <a:latin typeface="PingFang TC"/>
-                        </a:rPr>
-                        <a:t>【直擊小三連帶賠償】
-實務判賠約 30萬 ～ 100萬元。</a:t>
-                      </a:r>
-                    </a:p>
-                  </a:txBody>
-                  <a:tcPr>
-                    <a:solidFill>
-                      <a:srgbClr val="FFFFFF"/>
-                    </a:solidFill>
-                  </a:tcPr>
-                </a:tc>
-              </a:tr>
-              <a:tr h="932688">
-                <a:tc>
-                  <a:txBody>
-                    <a:bodyPr/>
-                    <a:lstStyle/>
-                    <a:p>
-                      <a:r>
-                        <a:rPr sz="1050" b="1">
-                          <a:solidFill>
-                            <a:srgbClr val="DE5814"/>
-                          </a:solidFill>
-                          <a:latin typeface="PingFang TC"/>
-                        </a:rPr>
-                        <a:t>判決離婚賠償
-與終身照護贍養費</a:t>
-                      </a:r>
-                    </a:p>
-                  </a:txBody>
-                  <a:tcPr>
-                    <a:solidFill>
-                      <a:srgbClr val="FFFDF7"/>
-                    </a:solidFill>
-                  </a:tcPr>
-                </a:tc>
-                <a:tc>
-                  <a:txBody>
-                    <a:bodyPr/>
-                    <a:lstStyle/>
-                    <a:p>
-                      <a:r>
-                        <a:rPr sz="1050">
-                          <a:solidFill>
-                            <a:srgbClr val="2D3748"/>
-                          </a:solidFill>
-                          <a:latin typeface="PingFang TC"/>
-                        </a:rPr>
-                        <a:t>民法第 1056 條
-民法第 1057 條</a:t>
-                      </a:r>
-                    </a:p>
-                  </a:txBody>
-                  <a:tcPr>
-                    <a:solidFill>
-                      <a:srgbClr val="FFFDF7"/>
-                    </a:solidFill>
-                  </a:tcPr>
-                </a:tc>
-                <a:tc>
-                  <a:txBody>
-                    <a:bodyPr/>
-                    <a:lstStyle/>
-                    <a:p>
-                      <a:r>
-                        <a:rPr sz="1050">
-                          <a:solidFill>
-                            <a:srgbClr val="2D3748"/>
-                          </a:solidFill>
-                          <a:latin typeface="PingFang TC"/>
-                        </a:rPr>
-                        <a:t>因可歸責父親事由致判決離婚之非財產損害；加計母親失智重症無謀生能力，判命按月或一次性給付外勞、醫療照護全額贍養費。</a:t>
-                      </a:r>
-                    </a:p>
-                  </a:txBody>
-                  <a:tcPr>
-                    <a:solidFill>
-                      <a:srgbClr val="FFFDF7"/>
-                    </a:solidFill>
-                  </a:tcPr>
-                </a:tc>
-                <a:tc>
-                  <a:txBody>
-                    <a:bodyPr/>
-                    <a:lstStyle/>
-                    <a:p>
-                      <a:r>
-                        <a:rPr sz="1050" b="1">
-                          <a:solidFill>
-                            <a:srgbClr val="A83212"/>
-                          </a:solidFill>
-                          <a:latin typeface="PingFang TC"/>
-                        </a:rPr>
-                        <a:t>【保障晚年尊嚴】
-外勞薪資+照護耗材，每月全額強制給付。</a:t>
-                      </a:r>
-                    </a:p>
-                  </a:txBody>
-                  <a:tcPr>
-                    <a:solidFill>
-                      <a:srgbClr val="FFFDF7"/>
-                    </a:solidFill>
-                  </a:tcPr>
-                </a:tc>
-              </a:tr>
-            </a:tbl>
-          </a:graphicData>
-        </a:graphic>
-      </p:graphicFrame>
-    </p:spTree>
-  </p:cSld>
-  <p:clrMapOvr>
-    <a:masterClrMapping/>
-  </p:clrMapOvr>
-</p:sld>
-</file>
-
-<file path=ppt/slides/slide6.xml><?xml version="1.0" encoding="utf-8"?>
-<p:sld xmlns:a="http://schemas.openxmlformats.org/drawingml/2006/main" xmlns:p="http://schemas.openxmlformats.org/presentationml/2006/main" xmlns:r="http://schemas.openxmlformats.org/officeDocument/2006/relationships">
-  <p:cSld>
-    <p:spTree>
-      <p:nvGrpSpPr>
-        <p:cNvPr id="1" name=""/>
-        <p:cNvGrpSpPr/>
-        <p:nvPr/>
-      </p:nvGrpSpPr>
-      <p:grpSpPr/>
-      <p:sp>
-        <p:nvSpPr>
-          <p:cNvPr id="2" name="Rectangle 1"/>
-          <p:cNvSpPr/>
-          <p:nvPr/>
-        </p:nvSpPr>
-        <p:spPr>
-          <a:xfrm>
-            <a:off x="731520" y="365760"/>
-            <a:ext cx="10728655" cy="36576"/>
-          </a:xfrm>
-          <a:prstGeom prst="rect">
+          <a:prstGeom prst="roundRect">
             <a:avLst/>
           </a:prstGeom>
           <a:solidFill>
-            <a:srgbClr val="D97706"/>
+            <a:srgbClr val="FFFBEB"/>
           </a:solidFill>
           <a:ln>
             <a:solidFill>
@@ -5343,376 +4750,45 @@
           </a:fontRef>
         </p:style>
         <p:txBody>
-          <a:bodyPr rtlCol="0" anchor="ctr"/>
+          <a:bodyPr rtlCol="0" anchor="ctr" wrap="square"/>
           <a:lstStyle/>
           <a:p>
             <a:pPr algn="ctr"/>
-          </a:p>
-        </p:txBody>
-      </p:sp>
-      <p:sp>
-        <p:nvSpPr>
-          <p:cNvPr id="3" name="TextBox 2"/>
-          <p:cNvSpPr txBox="1"/>
+            <a:r>
+              <a:rPr b="1" sz="1250">
+                <a:solidFill>
+                  <a:srgbClr val="DE5814"/>
+                </a:solidFill>
+              </a:rPr>
+              <a:t>【步驟 1：公所領表】 </a:t>
+            </a:r>
+            <a:r>
+              <a:rPr sz="1100">
+                <a:solidFill>
+                  <a:srgbClr val="2D3748"/>
+                </a:solidFill>
+              </a:rPr>
+              <a:t>先至戶籍地區公所領取身心障礙鑑定表（帶照片3張、身分證、印章）。</a:t>
+            </a:r>
+          </a:p>
+        </p:txBody>
+      </p:sp>
+      <p:sp>
+        <p:nvSpPr>
+          <p:cNvPr id="6" name="Rounded Rectangle 5"/>
+          <p:cNvSpPr/>
           <p:nvPr/>
         </p:nvSpPr>
         <p:spPr>
           <a:xfrm>
-            <a:off x="731520" y="457200"/>
-            <a:ext cx="10728655" cy="822960"/>
-          </a:xfrm>
-          <a:prstGeom prst="rect">
-            <a:avLst/>
-          </a:prstGeom>
-          <a:noFill/>
-        </p:spPr>
-        <p:txBody>
-          <a:bodyPr wrap="square" lIns="0" tIns="0" rIns="0" bIns="0">
-            <a:spAutoFit/>
-          </a:bodyPr>
-          <a:lstStyle/>
-          <a:p>
-            <a:r>
-              <a:rPr sz="1400" b="1">
-                <a:solidFill>
-                  <a:srgbClr val="A83212"/>
-                </a:solidFill>
-                <a:latin typeface="PingFang TC"/>
-              </a:rPr>
-              <a:t>【戰略決策】 </a:t>
-            </a:r>
-            <a:r>
-              <a:rPr sz="2400" b="1">
-                <a:solidFill>
-                  <a:srgbClr val="DE5814"/>
-                </a:solidFill>
-                <a:latin typeface="PingFang TC"/>
-              </a:rPr>
-              <a:t>核心戰略博弈：八旬長輩「離」與「不離」的極限抉擇</a:t>
-            </a:r>
-          </a:p>
-        </p:txBody>
-      </p:sp>
-      <p:sp>
-        <p:nvSpPr>
-          <p:cNvPr id="4" name="TextBox 3"/>
-          <p:cNvSpPr txBox="1"/>
-          <p:nvPr/>
-        </p:nvSpPr>
-        <p:spPr>
-          <a:xfrm>
-            <a:off x="731520" y="6400800"/>
-            <a:ext cx="10728655" cy="320040"/>
-          </a:xfrm>
-          <a:prstGeom prst="rect">
-            <a:avLst/>
-          </a:prstGeom>
-          <a:noFill/>
-        </p:spPr>
-        <p:txBody>
-          <a:bodyPr wrap="none">
-            <a:spAutoFit/>
-          </a:bodyPr>
-          <a:lstStyle/>
-          <a:p>
-            <a:r>
-              <a:rPr sz="1000">
-                <a:solidFill>
-                  <a:srgbClr val="8C96A5"/>
-                </a:solidFill>
-                <a:latin typeface="PingFang TC"/>
-              </a:rPr>
-              <a:t>八旬失智配偶法律防禦與權益最大化戰略報告 ｜ 報告人：Howard Liao Ph.D.(廖倫豪 博士)</a:t>
-            </a:r>
-          </a:p>
-        </p:txBody>
-      </p:sp>
-      <p:sp>
-        <p:nvSpPr>
-          <p:cNvPr id="5" name="Rounded Rectangle 4"/>
-          <p:cNvSpPr/>
-          <p:nvPr/>
-        </p:nvSpPr>
-        <p:spPr>
-          <a:xfrm>
-            <a:off x="731520" y="1463040"/>
-            <a:ext cx="5120640" cy="4663440"/>
+            <a:off x="731520" y="2267712"/>
+            <a:ext cx="10728655" cy="713232"/>
           </a:xfrm>
           <a:prstGeom prst="roundRect">
             <a:avLst/>
           </a:prstGeom>
           <a:solidFill>
             <a:srgbClr val="FFFBEB"/>
-          </a:solidFill>
-          <a:ln w="25400">
-            <a:solidFill>
-              <a:srgbClr val="A83212"/>
-            </a:solidFill>
-          </a:ln>
-        </p:spPr>
-        <p:style>
-          <a:lnRef idx="1">
-            <a:schemeClr val="accent1"/>
-          </a:lnRef>
-          <a:fillRef idx="3">
-            <a:schemeClr val="accent1"/>
-          </a:fillRef>
-          <a:effectRef idx="2">
-            <a:schemeClr val="accent1"/>
-          </a:effectRef>
-          <a:fontRef idx="minor">
-            <a:schemeClr val="lt1"/>
-          </a:fontRef>
-        </p:style>
-        <p:txBody>
-          <a:bodyPr rtlCol="0" anchor="ctr" wrap="square" lIns="274320" rIns="274320" tIns="274320"/>
-          <a:lstStyle/>
-          <a:p>
-            <a:pPr algn="ctr"/>
-            <a:r>
-              <a:rPr sz="1700" b="1">
-                <a:solidFill>
-                  <a:srgbClr val="A83212"/>
-                </a:solidFill>
-              </a:rPr>
-              <a:t>策略 A：堅決不離（以拖待變・遺產保全）
-</a:t>
-            </a:r>
-          </a:p>
-          <a:p>
-            <a:pPr>
-              <a:spcBef>
-                <a:spcPts val="1000"/>
-              </a:spcBef>
-            </a:pPr>
-            <a:r>
-              <a:rPr b="1" sz="1150">
-                <a:solidFill>
-                  <a:srgbClr val="D97706"/>
-                </a:solidFill>
-              </a:rPr>
-              <a:t>★ 法律防線極度堅固：
-</a:t>
-            </a:r>
-            <a:r>
-              <a:rPr sz="1050">
-                <a:solidFill>
-                  <a:srgbClr val="2D3748"/>
-                </a:solidFill>
-              </a:rPr>
-              <a:t>依民法第1052條第2項但書，外遇過失方無權強逼無過失生病原配離婚。法院極度排斥丟包病妻，判離機率極低。</a:t>
-            </a:r>
-          </a:p>
-          <a:p>
-            <a:pPr>
-              <a:spcBef>
-                <a:spcPts val="1000"/>
-              </a:spcBef>
-            </a:pPr>
-            <a:r>
-              <a:rPr b="1" sz="1150">
-                <a:solidFill>
-                  <a:srgbClr val="D97706"/>
-                </a:solidFill>
-              </a:rPr>
-              <a:t>★ 聲請強制生活費給付：
-</a:t>
-            </a:r>
-            <a:r>
-              <a:rPr sz="1050">
-                <a:solidFill>
-                  <a:srgbClr val="2D3748"/>
-                </a:solidFill>
-              </a:rPr>
-              <a:t>向法院聲請暫時處分，要求父親按月給付外籍看護費用與生活費，經濟無虞。</a:t>
-            </a:r>
-          </a:p>
-          <a:p>
-            <a:pPr>
-              <a:spcBef>
-                <a:spcPts val="1000"/>
-              </a:spcBef>
-            </a:pPr>
-            <a:r>
-              <a:rPr b="1" sz="1150">
-                <a:solidFill>
-                  <a:srgbClr val="D97706"/>
-                </a:solidFill>
-              </a:rPr>
-              <a:t>★ 【最大利益：合法繼承權】：
-</a:t>
-            </a:r>
-            <a:r>
-              <a:rPr sz="1050">
-                <a:solidFill>
-                  <a:srgbClr val="2D3748"/>
-                </a:solidFill>
-              </a:rPr>
-              <a:t>母親保有配偶第一順位法定繼承權！父親百年時，母親先拿剩餘財產一半，再與子女均分剩餘遺產。小三為法律局外人，一毛都分不到！</a:t>
-            </a:r>
-          </a:p>
-        </p:txBody>
-      </p:sp>
-      <p:sp>
-        <p:nvSpPr>
-          <p:cNvPr id="6" name="Rounded Rectangle 5"/>
-          <p:cNvSpPr/>
-          <p:nvPr/>
-        </p:nvSpPr>
-        <p:spPr>
-          <a:xfrm>
-            <a:off x="6309360" y="1463040"/>
-            <a:ext cx="5120640" cy="4663440"/>
-          </a:xfrm>
-          <a:prstGeom prst="roundRect">
-            <a:avLst/>
-          </a:prstGeom>
-          <a:solidFill>
-            <a:srgbClr val="FFFBEB"/>
-          </a:solidFill>
-          <a:ln w="25400">
-            <a:solidFill>
-              <a:srgbClr val="DE5814"/>
-            </a:solidFill>
-          </a:ln>
-        </p:spPr>
-        <p:style>
-          <a:lnRef idx="1">
-            <a:schemeClr val="accent1"/>
-          </a:lnRef>
-          <a:fillRef idx="3">
-            <a:schemeClr val="accent1"/>
-          </a:fillRef>
-          <a:effectRef idx="2">
-            <a:schemeClr val="accent1"/>
-          </a:effectRef>
-          <a:fontRef idx="minor">
-            <a:schemeClr val="lt1"/>
-          </a:fontRef>
-        </p:style>
-        <p:txBody>
-          <a:bodyPr rtlCol="0" anchor="ctr" wrap="square" lIns="274320" rIns="274320" tIns="274320"/>
-          <a:lstStyle/>
-          <a:p>
-            <a:pPr algn="ctr"/>
-            <a:r>
-              <a:rPr sz="1700" b="1">
-                <a:solidFill>
-                  <a:srgbClr val="DE5814"/>
-                </a:solidFill>
-              </a:rPr>
-              <a:t>策略 B：反訴離婚（即刻落袋・徹底切割）
-</a:t>
-            </a:r>
-          </a:p>
-          <a:p>
-            <a:pPr>
-              <a:spcBef>
-                <a:spcPts val="1000"/>
-              </a:spcBef>
-            </a:pPr>
-            <a:r>
-              <a:rPr b="1" sz="1150">
-                <a:solidFill>
-                  <a:srgbClr val="D97706"/>
-                </a:solidFill>
-              </a:rPr>
-              <a:t>★ 啟動時機：
-</a:t>
-            </a:r>
-            <a:r>
-              <a:rPr sz="1050">
-                <a:solidFill>
-                  <a:srgbClr val="2D3748"/>
-                </a:solidFill>
-              </a:rPr>
-              <a:t>發現父親正急速變賣房產、解約大額定存、密集贈與洗錢給小三，拖延恐遭掏空資產時採用。</a:t>
-            </a:r>
-          </a:p>
-          <a:p>
-            <a:pPr>
-              <a:spcBef>
-                <a:spcPts val="1000"/>
-              </a:spcBef>
-            </a:pPr>
-            <a:r>
-              <a:rPr b="1" sz="1150">
-                <a:solidFill>
-                  <a:srgbClr val="D97706"/>
-                </a:solidFill>
-              </a:rPr>
-              <a:t>★ 閃電強制假扣押：
-</a:t>
-            </a:r>
-            <a:r>
-              <a:rPr sz="1050">
-                <a:solidFill>
-                  <a:srgbClr val="2D3748"/>
-                </a:solidFill>
-              </a:rPr>
-              <a:t>立刻向法院反訴離婚，全面聲請假扣押查封其所有已知不動產與銀行帳戶。</a:t>
-            </a:r>
-          </a:p>
-          <a:p>
-            <a:pPr>
-              <a:spcBef>
-                <a:spcPts val="1000"/>
-              </a:spcBef>
-            </a:pPr>
-            <a:r>
-              <a:rPr b="1" sz="1150">
-                <a:solidFill>
-                  <a:srgbClr val="D97706"/>
-                </a:solidFill>
-              </a:rPr>
-              <a:t>★ 【最大利益：落袋為安信託】：
-</a:t>
-            </a:r>
-            <a:r>
-              <a:rPr sz="1050">
-                <a:solidFill>
-                  <a:srgbClr val="2D3748"/>
-                </a:solidFill>
-              </a:rPr>
-              <a:t>依判決強制執行將數千萬產權與存款平分登記至母親名下。由監護人設立「高齡安養信託」，確保母親醫療與照護安享晚年。</a:t>
-            </a:r>
-          </a:p>
-        </p:txBody>
-      </p:sp>
-    </p:spTree>
-  </p:cSld>
-  <p:clrMapOvr>
-    <a:masterClrMapping/>
-  </p:clrMapOvr>
-</p:sld>
-</file>
-
-<file path=ppt/slides/slide7.xml><?xml version="1.0" encoding="utf-8"?>
-<p:sld xmlns:a="http://schemas.openxmlformats.org/drawingml/2006/main" xmlns:p="http://schemas.openxmlformats.org/presentationml/2006/main" xmlns:r="http://schemas.openxmlformats.org/officeDocument/2006/relationships">
-  <p:cSld>
-    <p:spTree>
-      <p:nvGrpSpPr>
-        <p:cNvPr id="1" name=""/>
-        <p:cNvGrpSpPr/>
-        <p:nvPr/>
-      </p:nvGrpSpPr>
-      <p:grpSpPr/>
-      <p:sp>
-        <p:nvSpPr>
-          <p:cNvPr id="2" name="Rectangle 1"/>
-          <p:cNvSpPr/>
-          <p:nvPr/>
-        </p:nvSpPr>
-        <p:spPr>
-          <a:xfrm>
-            <a:off x="731520" y="365760"/>
-            <a:ext cx="10728655" cy="36576"/>
-          </a:xfrm>
-          <a:prstGeom prst="rect">
-            <a:avLst/>
-          </a:prstGeom>
-          <a:solidFill>
-            <a:srgbClr val="D97706"/>
           </a:solidFill>
           <a:ln>
             <a:solidFill>
@@ -5735,124 +4811,39 @@
           </a:fontRef>
         </p:style>
         <p:txBody>
-          <a:bodyPr rtlCol="0" anchor="ctr"/>
+          <a:bodyPr rtlCol="0" anchor="ctr" wrap="square"/>
           <a:lstStyle/>
           <a:p>
             <a:pPr algn="ctr"/>
-          </a:p>
-        </p:txBody>
-      </p:sp>
-      <p:sp>
-        <p:nvSpPr>
-          <p:cNvPr id="3" name="TextBox 2"/>
-          <p:cNvSpPr txBox="1"/>
+            <a:r>
+              <a:rPr b="1" sz="1250">
+                <a:solidFill>
+                  <a:srgbClr val="DE5814"/>
+                </a:solidFill>
+              </a:rPr>
+              <a:t>【步驟 2：榮總開診斷書】 </a:t>
+            </a:r>
+            <a:r>
+              <a:rPr sz="1100">
+                <a:solidFill>
+                  <a:srgbClr val="2D3748"/>
+                </a:solidFill>
+              </a:rPr>
+              <a:t>請醫師開立載明「CDR失智、不能為意思表示、24小時專人看護」之專業診斷書並遞交身障鑑定。</a:t>
+            </a:r>
+          </a:p>
+        </p:txBody>
+      </p:sp>
+      <p:sp>
+        <p:nvSpPr>
+          <p:cNvPr id="7" name="Rounded Rectangle 6"/>
+          <p:cNvSpPr/>
           <p:nvPr/>
         </p:nvSpPr>
         <p:spPr>
           <a:xfrm>
-            <a:off x="731520" y="457200"/>
-            <a:ext cx="10728655" cy="822960"/>
-          </a:xfrm>
-          <a:prstGeom prst="rect">
-            <a:avLst/>
-          </a:prstGeom>
-          <a:noFill/>
-        </p:spPr>
-        <p:txBody>
-          <a:bodyPr wrap="square" lIns="0" tIns="0" rIns="0" bIns="0">
-            <a:spAutoFit/>
-          </a:bodyPr>
-          <a:lstStyle/>
-          <a:p>
-            <a:r>
-              <a:rPr sz="1400" b="1">
-                <a:solidFill>
-                  <a:srgbClr val="A83212"/>
-                </a:solidFill>
-                <a:latin typeface="PingFang TC"/>
-              </a:rPr>
-              <a:t>【行動時程】 </a:t>
-            </a:r>
-            <a:r>
-              <a:rPr sz="2400" b="1">
-                <a:solidFill>
-                  <a:srgbClr val="DE5814"/>
-                </a:solidFill>
-                <a:latin typeface="PingFang TC"/>
-              </a:rPr>
-              <a:t>實戰執行 SOP 推進時程與家屬行動檢核</a:t>
-            </a:r>
-          </a:p>
-        </p:txBody>
-      </p:sp>
-      <p:sp>
-        <p:nvSpPr>
-          <p:cNvPr id="4" name="TextBox 3"/>
-          <p:cNvSpPr txBox="1"/>
-          <p:nvPr/>
-        </p:nvSpPr>
-        <p:spPr>
-          <a:xfrm>
-            <a:off x="731520" y="6400800"/>
-            <a:ext cx="10728655" cy="320040"/>
-          </a:xfrm>
-          <a:prstGeom prst="rect">
-            <a:avLst/>
-          </a:prstGeom>
-          <a:noFill/>
-        </p:spPr>
-        <p:txBody>
-          <a:bodyPr wrap="none">
-            <a:spAutoFit/>
-          </a:bodyPr>
-          <a:lstStyle/>
-          <a:p>
-            <a:r>
-              <a:rPr sz="1000">
-                <a:solidFill>
-                  <a:srgbClr val="8C96A5"/>
-                </a:solidFill>
-                <a:latin typeface="PingFang TC"/>
-              </a:rPr>
-              <a:t>八旬失智配偶法律防禦與權益最大化戰略報告 ｜ 報告人：Howard Liao Ph.D.(廖倫豪 博士)</a:t>
-            </a:r>
-          </a:p>
-        </p:txBody>
-      </p:sp>
-      <p:pic>
-        <p:nvPicPr>
-          <p:cNvPr id="5" name="Picture 4" descr="icon_pyramid.png"/>
-          <p:cNvPicPr>
-            <a:picLocks noChangeAspect="1"/>
-          </p:cNvPicPr>
-          <p:nvPr/>
-        </p:nvPicPr>
-        <p:blipFill>
-          <a:blip r:embed="rId2"/>
-          <a:stretch>
-            <a:fillRect/>
-          </a:stretch>
-        </p:blipFill>
-        <p:spPr>
-          <a:xfrm>
-            <a:off x="10241280" y="457200"/>
-            <a:ext cx="1371600" cy="1371600"/>
-          </a:xfrm>
-          <a:prstGeom prst="rect">
-            <a:avLst/>
-          </a:prstGeom>
-        </p:spPr>
-      </p:pic>
-      <p:sp>
-        <p:nvSpPr>
-          <p:cNvPr id="6" name="Rounded Rectangle 5"/>
-          <p:cNvSpPr/>
-          <p:nvPr/>
-        </p:nvSpPr>
-        <p:spPr>
-          <a:xfrm>
-            <a:off x="731520" y="1463040"/>
-            <a:ext cx="9326880" cy="1051560"/>
+            <a:off x="731520" y="3072384"/>
+            <a:ext cx="10728655" cy="713232"/>
           </a:xfrm>
           <a:prstGeom prst="roundRect">
             <a:avLst/>
@@ -5860,7 +4851,7 @@
           <a:solidFill>
             <a:srgbClr val="FFFBEB"/>
           </a:solidFill>
-          <a:ln w="12700">
+          <a:ln>
             <a:solidFill>
               <a:srgbClr val="D97706"/>
             </a:solidFill>
@@ -5881,41 +4872,39 @@
           </a:fontRef>
         </p:style>
         <p:txBody>
-          <a:bodyPr rtlCol="0" anchor="ctr" wrap="square" lIns="164592" rIns="164592" tIns="164592"/>
+          <a:bodyPr rtlCol="0" anchor="ctr" wrap="square"/>
           <a:lstStyle/>
           <a:p>
             <a:pPr algn="ctr"/>
             <a:r>
-              <a:rPr sz="1300" b="1">
+              <a:rPr b="1" sz="1250">
                 <a:solidFill>
                   <a:srgbClr val="DE5814"/>
                 </a:solidFill>
-                <a:latin typeface="PingFang TC"/>
               </a:rPr>
-              <a:t>【第一階段（即刻~2週內）】 醫院鑑定與證明開立： </a:t>
-            </a:r>
-            <a:r>
-              <a:rPr sz="1050">
+              <a:t>【步驟 3：調證查底牌】 </a:t>
+            </a:r>
+            <a:r>
+              <a:rPr sz="1100">
                 <a:solidFill>
                   <a:srgbClr val="2D3748"/>
                 </a:solidFill>
-                <a:latin typeface="PingFang TC"/>
               </a:rPr>
-              <a:t>帶母親至台中榮總神經內科就醫；同步開妥載明「CDR失智、無辨識意思能力、24小時專人看護」之訴訟診斷書；攜帶公所表格完成身心障礙鑑定遞件。</a:t>
-            </a:r>
-          </a:p>
-        </p:txBody>
-      </p:sp>
-      <p:sp>
-        <p:nvSpPr>
-          <p:cNvPr id="7" name="Rounded Rectangle 6"/>
+              <a:t>地政調「異動索引」鎖定過戶給湛明輝鐵證；國稅局查財產總歸戶與近三年所得。</a:t>
+            </a:r>
+          </a:p>
+        </p:txBody>
+      </p:sp>
+      <p:sp>
+        <p:nvSpPr>
+          <p:cNvPr id="8" name="Rounded Rectangle 7"/>
           <p:cNvSpPr/>
           <p:nvPr/>
         </p:nvSpPr>
         <p:spPr>
           <a:xfrm>
-            <a:off x="731520" y="2651760"/>
-            <a:ext cx="9326880" cy="1051560"/>
+            <a:off x="731520" y="3877056"/>
+            <a:ext cx="10728655" cy="713232"/>
           </a:xfrm>
           <a:prstGeom prst="roundRect">
             <a:avLst/>
@@ -5923,7 +4912,7 @@
           <a:solidFill>
             <a:srgbClr val="FFFBEB"/>
           </a:solidFill>
-          <a:ln w="12700">
+          <a:ln>
             <a:solidFill>
               <a:srgbClr val="D97706"/>
             </a:solidFill>
@@ -5944,41 +4933,39 @@
           </a:fontRef>
         </p:style>
         <p:txBody>
-          <a:bodyPr rtlCol="0" anchor="ctr" wrap="square" lIns="164592" rIns="164592" tIns="164592"/>
+          <a:bodyPr rtlCol="0" anchor="ctr" wrap="square"/>
           <a:lstStyle/>
           <a:p>
             <a:pPr algn="ctr"/>
             <a:r>
-              <a:rPr sz="1300" b="1">
+              <a:rPr b="1" sz="1250">
                 <a:solidFill>
                   <a:srgbClr val="DE5814"/>
                 </a:solidFill>
-                <a:latin typeface="PingFang TC"/>
               </a:rPr>
-              <a:t>【第二階段（第2~4週）】 監護宣告與財產清查： </a:t>
-            </a:r>
-            <a:r>
-              <a:rPr sz="1050">
+              <a:t>【步驟 4：聲請監護宣告】 </a:t>
+            </a:r>
+            <a:r>
+              <a:rPr sz="1100">
                 <a:solidFill>
                   <a:srgbClr val="2D3748"/>
                 </a:solidFill>
-                <a:latin typeface="PingFang TC"/>
               </a:rPr>
-              <a:t>向家事法院具狀聲請「監護宣告」指派子女為監護人；向國稅局調閱父母雙方全國財產總歸戶清單及近三年綜所稅各類所得資料，徹底摸清資產底牌。</a:t>
-            </a:r>
-          </a:p>
-        </p:txBody>
-      </p:sp>
-      <p:sp>
-        <p:nvSpPr>
-          <p:cNvPr id="8" name="Rounded Rectangle 7"/>
+              <a:t>檢附診斷書向家事法院聲請監護宣告，指定子女任法定監護人代理一切法律行為。</a:t>
+            </a:r>
+          </a:p>
+        </p:txBody>
+      </p:sp>
+      <p:sp>
+        <p:nvSpPr>
+          <p:cNvPr id="9" name="Rounded Rectangle 8"/>
           <p:cNvSpPr/>
           <p:nvPr/>
         </p:nvSpPr>
         <p:spPr>
           <a:xfrm>
-            <a:off x="731520" y="3840480"/>
-            <a:ext cx="9326880" cy="1051560"/>
+            <a:off x="731520" y="4681728"/>
+            <a:ext cx="10728655" cy="713232"/>
           </a:xfrm>
           <a:prstGeom prst="roundRect">
             <a:avLst/>
@@ -5986,7 +4973,7 @@
           <a:solidFill>
             <a:srgbClr val="FFFBEB"/>
           </a:solidFill>
-          <a:ln w="12700">
+          <a:ln>
             <a:solidFill>
               <a:srgbClr val="D97706"/>
             </a:solidFill>
@@ -6007,41 +4994,39 @@
           </a:fontRef>
         </p:style>
         <p:txBody>
-          <a:bodyPr rtlCol="0" anchor="ctr" wrap="square" lIns="164592" rIns="164592" tIns="164592"/>
+          <a:bodyPr rtlCol="0" anchor="ctr" wrap="square"/>
           <a:lstStyle/>
           <a:p>
             <a:pPr algn="ctr"/>
             <a:r>
-              <a:rPr sz="1300" b="1">
+              <a:rPr b="1" sz="1250">
                 <a:solidFill>
                   <a:srgbClr val="DE5814"/>
                 </a:solidFill>
-                <a:latin typeface="PingFang TC"/>
               </a:rPr>
-              <a:t>【第三階段（第1~2個月）】 資產凍結與暫時處分： </a:t>
-            </a:r>
-            <a:r>
-              <a:rPr sz="1050">
+              <a:t>【步驟 5：聲請假扣押】 </a:t>
+            </a:r>
+            <a:r>
+              <a:rPr sz="1100">
                 <a:solidFill>
                   <a:srgbClr val="2D3748"/>
                 </a:solidFill>
-                <a:latin typeface="PingFang TC"/>
               </a:rPr>
-              <a:t>由委任律師向法院聲請「夫妻財產保全處分／假扣押」，全面凍結父親名下不動產與定存；聲請暫時處分強制父親按月匯給外勞薪資與生活照料費。</a:t>
-            </a:r>
-          </a:p>
-        </p:txBody>
-      </p:sp>
-      <p:sp>
-        <p:nvSpPr>
-          <p:cNvPr id="9" name="Rounded Rectangle 8"/>
+              <a:t>對廖光輝與湛明輝名下資產聲請假扣押查封，聲請暫時處分命每月支付看護費。</a:t>
+            </a:r>
+          </a:p>
+        </p:txBody>
+      </p:sp>
+      <p:sp>
+        <p:nvSpPr>
+          <p:cNvPr id="10" name="Rounded Rectangle 9"/>
           <p:cNvSpPr/>
           <p:nvPr/>
         </p:nvSpPr>
         <p:spPr>
           <a:xfrm>
-            <a:off x="731520" y="5029200"/>
-            <a:ext cx="9326880" cy="1051560"/>
+            <a:off x="731520" y="5486400"/>
+            <a:ext cx="10728655" cy="713232"/>
           </a:xfrm>
           <a:prstGeom prst="roundRect">
             <a:avLst/>
@@ -6049,7 +5034,7 @@
           <a:solidFill>
             <a:srgbClr val="FFFBEB"/>
           </a:solidFill>
-          <a:ln w="12700">
+          <a:ln>
             <a:solidFill>
               <a:srgbClr val="D97706"/>
             </a:solidFill>
@@ -6070,27 +5055,25 @@
           </a:fontRef>
         </p:style>
         <p:txBody>
-          <a:bodyPr rtlCol="0" anchor="ctr" wrap="square" lIns="164592" rIns="164592" tIns="164592"/>
+          <a:bodyPr rtlCol="0" anchor="ctr" wrap="square"/>
           <a:lstStyle/>
           <a:p>
             <a:pPr algn="ctr"/>
             <a:r>
-              <a:rPr sz="1300" b="1">
+              <a:rPr b="1" sz="1250">
                 <a:solidFill>
                   <a:srgbClr val="DE5814"/>
                 </a:solidFill>
-                <a:latin typeface="PingFang TC"/>
               </a:rPr>
-              <a:t>【第四階段（第2~6個月）】 實體法庭反擊與求償： </a:t>
-            </a:r>
-            <a:r>
-              <a:rPr sz="1050">
+              <a:t>【步驟 6：實體訴訟反擊】 </a:t>
+            </a:r>
+            <a:r>
+              <a:rPr sz="1100">
                 <a:solidFill>
                   <a:srgbClr val="2D3748"/>
                 </a:solidFill>
-                <a:latin typeface="PingFang TC"/>
               </a:rPr>
-              <a:t>連帶控告父親與小三侵害配偶權（求償百萬）；在家事法庭以民法第1052條但書阻斷惡意離婚，或發動民法第1030-1剩餘財產平分與第1030-3追討小三全數資產。</a:t>
+              <a:t>共同起訴兩人侵害配偶權；法庭運用民法1052但書拒離，或反訴1030-3追討財產。</a:t>
             </a:r>
           </a:p>
         </p:txBody>

</xml_diff>